<commit_message>
Update presentation files and build script for English version
- Renamed final PowerPoint deck to 'screen_normalize_final_6min_en.pptx' for English version and retained the Chinese backup as 'screen_normalize_final_6min.pptx'.
- Updated the build script to output the English deck and changed font settings to Aptos.
- Revised slide content to reflect English translations, including titles, notes, and text.
- Added a new directory for final PowerPoint-rendered QA previews for the English deck.
</commit_message>
<xml_diff>
--- a/projects/screen_normalize_report_ppt169_20260714/exports/screen_normalize_final_6min.pptx
+++ b/projects/screen_normalize_report_ppt169_20260714/exports/screen_normalize_final_6min.pptx
@@ -4,17 +4,20 @@
   <p:sldMasterIdLst>
     <p:sldMasterId id="2147483648" r:id="rId1"/>
   </p:sldMasterIdLst>
+  <p:notesMasterIdLst>
+    <p:notesMasterId r:id="rId10"/>
+  </p:notesMasterIdLst>
   <p:sldIdLst>
-    <p:sldId id="256" r:id="rId7"/>
-    <p:sldId id="257" r:id="rId9"/>
-    <p:sldId id="258" r:id="rId10"/>
-    <p:sldId id="259" r:id="rId11"/>
-    <p:sldId id="260" r:id="rId12"/>
-    <p:sldId id="261" r:id="rId13"/>
-    <p:sldId id="262" r:id="rId14"/>
-    <p:sldId id="263" r:id="rId15"/>
+    <p:sldId id="256" r:id="rId2"/>
+    <p:sldId id="257" r:id="rId3"/>
+    <p:sldId id="258" r:id="rId4"/>
+    <p:sldId id="259" r:id="rId5"/>
+    <p:sldId id="260" r:id="rId6"/>
+    <p:sldId id="261" r:id="rId7"/>
+    <p:sldId id="262" r:id="rId8"/>
+    <p:sldId id="263" r:id="rId9"/>
   </p:sldIdLst>
-  <p:sldSz cx="12191695" cy="6858000" type="screen4x3"/>
+  <p:sldSz cx="12192000" cy="6858000"/>
   <p:notesSz cx="6858000" cy="9144000"/>
   <p:defaultTextStyle>
     <a:defPPr>
@@ -111,11 +114,27 @@
       </a:defRPr>
     </a:lvl9pPr>
   </p:defaultTextStyle>
+  <p:extLst>
+    <p:ext uri="{EFAFB233-063F-42B5-8137-9DF3F51BA10A}">
+      <p15:sldGuideLst xmlns:p15="http://schemas.microsoft.com/office/powerpoint/2012/main">
+        <p15:guide id="1" orient="horz" pos="2160">
+          <p15:clr>
+            <a:srgbClr val="A4A3A4"/>
+          </p15:clr>
+        </p15:guide>
+        <p15:guide id="2" pos="2880">
+          <p15:clr>
+            <a:srgbClr val="A4A3A4"/>
+          </p15:clr>
+        </p15:guide>
+      </p15:sldGuideLst>
+    </p:ext>
+  </p:extLst>
 </p:presentation>
 </file>
 
 <file path=ppt/notesMasters/notesMaster1.xml><?xml version="1.0" encoding="utf-8"?>
-<p:notesMaster xmlns:a="http://schemas.openxmlformats.org/drawingml/2006/main" xmlns:p="http://schemas.openxmlformats.org/presentationml/2006/main" xmlns:r="http://schemas.openxmlformats.org/officeDocument/2006/relationships">
+<p:notesMaster xmlns:a="http://schemas.openxmlformats.org/drawingml/2006/main" xmlns:r="http://schemas.openxmlformats.org/officeDocument/2006/relationships" xmlns:p="http://schemas.openxmlformats.org/presentationml/2006/main">
   <p:cSld>
     <p:bg>
       <p:bgRef idx="1001">
@@ -136,241 +155,16 @@
           <a:chExt cx="0" cy="0"/>
         </a:xfrm>
       </p:grpSpPr>
-      <p:sp>
-        <p:nvSpPr>
-          <p:cNvPr id="2" name="Header Placeholder 1"/>
-          <p:cNvSpPr>
-            <a:spLocks noGrp="1"/>
-          </p:cNvSpPr>
-          <p:nvPr>
-            <p:ph type="hdr" sz="quarter"/>
-          </p:nvPr>
-        </p:nvSpPr>
-        <p:spPr>
-          <a:xfrm>
-            <a:off x="0" y="0"/>
-            <a:ext cx="2971800" cy="457200"/>
-          </a:xfrm>
-          <a:prstGeom prst="rect">
-            <a:avLst/>
-          </a:prstGeom>
-        </p:spPr>
-        <p:txBody>
-          <a:bodyPr vert="horz" lIns="91440" tIns="45720" rIns="91440" bIns="45720" rtlCol="0"/>
-          <a:lstStyle>
-            <a:lvl1pPr algn="l">
-              <a:defRPr sz="1200"/>
-            </a:lvl1pPr>
-          </a:lstStyle>
-          <a:p>
-            <a:endParaRPr lang="en-US"/>
-          </a:p>
-        </p:txBody>
-      </p:sp>
-      <p:sp>
-        <p:nvSpPr>
-          <p:cNvPr id="3" name="Date Placeholder 2"/>
-          <p:cNvSpPr>
-            <a:spLocks noGrp="1"/>
-          </p:cNvSpPr>
-          <p:nvPr>
-            <p:ph type="dt" idx="1"/>
-          </p:nvPr>
-        </p:nvSpPr>
-        <p:spPr>
-          <a:xfrm>
-            <a:off x="3884613" y="0"/>
-            <a:ext cx="2971800" cy="457200"/>
-          </a:xfrm>
-          <a:prstGeom prst="rect">
-            <a:avLst/>
-          </a:prstGeom>
-        </p:spPr>
-        <p:txBody>
-          <a:bodyPr vert="horz" lIns="91440" tIns="45720" rIns="91440" bIns="45720" rtlCol="0"/>
-          <a:lstStyle>
-            <a:lvl1pPr algn="r">
-              <a:defRPr sz="1200"/>
-            </a:lvl1pPr>
-          </a:lstStyle>
-          <a:p>
-            <a:fld id="{0F89C1C7-3DCD-1040-A9CF-14679D8B5DDD}" type="datetimeFigureOut">
-              <a:rPr lang="en-US" smtClean="0"/>
-              <a:t>10/17/16</a:t>
-            </a:fld>
-            <a:endParaRPr lang="en-US"/>
-          </a:p>
-        </p:txBody>
-      </p:sp>
-      <p:sp>
-        <p:nvSpPr>
-          <p:cNvPr id="4" name="Slide Image Placeholder 3"/>
-          <p:cNvSpPr>
-            <a:spLocks noGrp="1" noRot="1" noChangeAspect="1"/>
-          </p:cNvSpPr>
-          <p:nvPr>
-            <p:ph type="sldImg" idx="2"/>
-          </p:nvPr>
-        </p:nvSpPr>
-        <p:spPr>
-          <a:xfrm>
-            <a:off x="1143000" y="685800"/>
-            <a:ext cx="4572000" cy="3429000"/>
-          </a:xfrm>
-          <a:prstGeom prst="rect">
-            <a:avLst/>
-          </a:prstGeom>
-          <a:noFill/>
-          <a:ln w="12700">
-            <a:solidFill>
-              <a:prstClr val="black"/>
-            </a:solidFill>
-          </a:ln>
-        </p:spPr>
-        <p:txBody>
-          <a:bodyPr vert="horz" lIns="91440" tIns="45720" rIns="91440" bIns="45720" rtlCol="0" anchor="ctr"/>
-          <a:lstStyle/>
-          <a:p>
-            <a:endParaRPr lang="en-US"/>
-          </a:p>
-        </p:txBody>
-      </p:sp>
-      <p:sp>
-        <p:nvSpPr>
-          <p:cNvPr id="5" name="Notes Placeholder 4"/>
-          <p:cNvSpPr>
-            <a:spLocks noGrp="1"/>
-          </p:cNvSpPr>
-          <p:nvPr>
-            <p:ph type="body" sz="quarter" idx="3"/>
-          </p:nvPr>
-        </p:nvSpPr>
-        <p:spPr>
-          <a:xfrm>
-            <a:off x="685800" y="4343400"/>
-            <a:ext cx="5486400" cy="4114800"/>
-          </a:xfrm>
-          <a:prstGeom prst="rect">
-            <a:avLst/>
-          </a:prstGeom>
-        </p:spPr>
-        <p:txBody>
-          <a:bodyPr vert="horz" lIns="91440" tIns="45720" rIns="91440" bIns="45720" rtlCol="0"/>
-          <a:lstStyle/>
-          <a:p>
-            <a:pPr lvl="0"/>
-            <a:r>
-              <a:rPr lang="en-US" smtClean="0"/>
-              <a:t>Click to edit Master text styles</a:t>
-            </a:r>
-          </a:p>
-          <a:p>
-            <a:pPr lvl="1"/>
-            <a:r>
-              <a:rPr lang="en-US" smtClean="0"/>
-              <a:t>Second level</a:t>
-            </a:r>
-          </a:p>
-          <a:p>
-            <a:pPr lvl="2"/>
-            <a:r>
-              <a:rPr lang="en-US" smtClean="0"/>
-              <a:t>Third level</a:t>
-            </a:r>
-          </a:p>
-          <a:p>
-            <a:pPr lvl="3"/>
-            <a:r>
-              <a:rPr lang="en-US" smtClean="0"/>
-              <a:t>Fourth level</a:t>
-            </a:r>
-          </a:p>
-          <a:p>
-            <a:pPr lvl="4"/>
-            <a:r>
-              <a:rPr lang="en-US" smtClean="0"/>
-              <a:t>Fifth level</a:t>
-            </a:r>
-            <a:endParaRPr lang="en-US"/>
-          </a:p>
-        </p:txBody>
-      </p:sp>
-      <p:sp>
-        <p:nvSpPr>
-          <p:cNvPr id="6" name="Footer Placeholder 5"/>
-          <p:cNvSpPr>
-            <a:spLocks noGrp="1"/>
-          </p:cNvSpPr>
-          <p:nvPr>
-            <p:ph type="ftr" sz="quarter" idx="4"/>
-          </p:nvPr>
-        </p:nvSpPr>
-        <p:spPr>
-          <a:xfrm>
-            <a:off x="0" y="8685213"/>
-            <a:ext cx="2971800" cy="457200"/>
-          </a:xfrm>
-          <a:prstGeom prst="rect">
-            <a:avLst/>
-          </a:prstGeom>
-        </p:spPr>
-        <p:txBody>
-          <a:bodyPr vert="horz" lIns="91440" tIns="45720" rIns="91440" bIns="45720" rtlCol="0" anchor="b"/>
-          <a:lstStyle>
-            <a:lvl1pPr algn="l">
-              <a:defRPr sz="1200"/>
-            </a:lvl1pPr>
-          </a:lstStyle>
-          <a:p>
-            <a:endParaRPr lang="en-US"/>
-          </a:p>
-        </p:txBody>
-      </p:sp>
-      <p:sp>
-        <p:nvSpPr>
-          <p:cNvPr id="7" name="Slide Number Placeholder 6"/>
-          <p:cNvSpPr>
-            <a:spLocks noGrp="1"/>
-          </p:cNvSpPr>
-          <p:nvPr>
-            <p:ph type="sldNum" sz="quarter" idx="5"/>
-          </p:nvPr>
-        </p:nvSpPr>
-        <p:spPr>
-          <a:xfrm>
-            <a:off x="3884613" y="8685213"/>
-            <a:ext cx="2971800" cy="457200"/>
-          </a:xfrm>
-          <a:prstGeom prst="rect">
-            <a:avLst/>
-          </a:prstGeom>
-        </p:spPr>
-        <p:txBody>
-          <a:bodyPr vert="horz" lIns="91440" tIns="45720" rIns="91440" bIns="45720" rtlCol="0" anchor="b"/>
-          <a:lstStyle>
-            <a:lvl1pPr algn="r">
-              <a:defRPr sz="1200"/>
-            </a:lvl1pPr>
-          </a:lstStyle>
-          <a:p>
-            <a:fld id="{BB5E49A5-4136-284D-997B-48E1D791AD67}" type="slidenum">
-              <a:rPr lang="en-US" smtClean="0"/>
-              <a:t>‹#›</a:t>
-            </a:fld>
-            <a:endParaRPr lang="en-US"/>
-          </a:p>
-        </p:txBody>
-      </p:sp>
     </p:spTree>
     <p:extLst>
       <p:ext uri="{BB962C8B-B14F-4D97-AF65-F5344CB8AC3E}">
-        <p14:creationId xmlns:p14="http://schemas.microsoft.com/office/powerpoint/2010/main" val="2623252185"/>
+        <p14:creationId xmlns:p14="http://schemas.microsoft.com/office/powerpoint/2010/main" val="2288582657"/>
       </p:ext>
     </p:extLst>
   </p:cSld>
   <p:clrMap bg1="lt1" tx1="dk1" bg2="lt2" tx2="dk2" accent1="accent1" accent2="accent2" accent3="accent3" accent4="accent4" accent5="accent5" accent6="accent6" hlink="hlink" folHlink="folHlink"/>
   <p:notesStyle>
-    <a:lvl1pPr marL="0" algn="l" defTabSz="457200" rtl="0" eaLnBrk="1" latinLnBrk="0" hangingPunct="1">
+    <a:lvl1pPr marL="0" algn="l" defTabSz="914400" rtl="0" eaLnBrk="1" latinLnBrk="0" hangingPunct="1">
       <a:defRPr sz="1200" kern="1200">
         <a:solidFill>
           <a:schemeClr val="tx1"/>
@@ -380,7 +174,7 @@
         <a:cs typeface="+mn-cs"/>
       </a:defRPr>
     </a:lvl1pPr>
-    <a:lvl2pPr marL="457200" algn="l" defTabSz="457200" rtl="0" eaLnBrk="1" latinLnBrk="0" hangingPunct="1">
+    <a:lvl2pPr marL="457200" algn="l" defTabSz="914400" rtl="0" eaLnBrk="1" latinLnBrk="0" hangingPunct="1">
       <a:defRPr sz="1200" kern="1200">
         <a:solidFill>
           <a:schemeClr val="tx1"/>
@@ -390,7 +184,7 @@
         <a:cs typeface="+mn-cs"/>
       </a:defRPr>
     </a:lvl2pPr>
-    <a:lvl3pPr marL="914400" algn="l" defTabSz="457200" rtl="0" eaLnBrk="1" latinLnBrk="0" hangingPunct="1">
+    <a:lvl3pPr marL="914400" algn="l" defTabSz="914400" rtl="0" eaLnBrk="1" latinLnBrk="0" hangingPunct="1">
       <a:defRPr sz="1200" kern="1200">
         <a:solidFill>
           <a:schemeClr val="tx1"/>
@@ -400,7 +194,7 @@
         <a:cs typeface="+mn-cs"/>
       </a:defRPr>
     </a:lvl3pPr>
-    <a:lvl4pPr marL="1371600" algn="l" defTabSz="457200" rtl="0" eaLnBrk="1" latinLnBrk="0" hangingPunct="1">
+    <a:lvl4pPr marL="1371600" algn="l" defTabSz="914400" rtl="0" eaLnBrk="1" latinLnBrk="0" hangingPunct="1">
       <a:defRPr sz="1200" kern="1200">
         <a:solidFill>
           <a:schemeClr val="tx1"/>
@@ -410,7 +204,7 @@
         <a:cs typeface="+mn-cs"/>
       </a:defRPr>
     </a:lvl4pPr>
-    <a:lvl5pPr marL="1828800" algn="l" defTabSz="457200" rtl="0" eaLnBrk="1" latinLnBrk="0" hangingPunct="1">
+    <a:lvl5pPr marL="1828800" algn="l" defTabSz="914400" rtl="0" eaLnBrk="1" latinLnBrk="0" hangingPunct="1">
       <a:defRPr sz="1200" kern="1200">
         <a:solidFill>
           <a:schemeClr val="tx1"/>
@@ -420,7 +214,7 @@
         <a:cs typeface="+mn-cs"/>
       </a:defRPr>
     </a:lvl5pPr>
-    <a:lvl6pPr marL="2286000" algn="l" defTabSz="457200" rtl="0" eaLnBrk="1" latinLnBrk="0" hangingPunct="1">
+    <a:lvl6pPr marL="2286000" algn="l" defTabSz="914400" rtl="0" eaLnBrk="1" latinLnBrk="0" hangingPunct="1">
       <a:defRPr sz="1200" kern="1200">
         <a:solidFill>
           <a:schemeClr val="tx1"/>
@@ -430,7 +224,7 @@
         <a:cs typeface="+mn-cs"/>
       </a:defRPr>
     </a:lvl6pPr>
-    <a:lvl7pPr marL="2743200" algn="l" defTabSz="457200" rtl="0" eaLnBrk="1" latinLnBrk="0" hangingPunct="1">
+    <a:lvl7pPr marL="2743200" algn="l" defTabSz="914400" rtl="0" eaLnBrk="1" latinLnBrk="0" hangingPunct="1">
       <a:defRPr sz="1200" kern="1200">
         <a:solidFill>
           <a:schemeClr val="tx1"/>
@@ -440,7 +234,7 @@
         <a:cs typeface="+mn-cs"/>
       </a:defRPr>
     </a:lvl7pPr>
-    <a:lvl8pPr marL="3200400" algn="l" defTabSz="457200" rtl="0" eaLnBrk="1" latinLnBrk="0" hangingPunct="1">
+    <a:lvl8pPr marL="3200400" algn="l" defTabSz="914400" rtl="0" eaLnBrk="1" latinLnBrk="0" hangingPunct="1">
       <a:defRPr sz="1200" kern="1200">
         <a:solidFill>
           <a:schemeClr val="tx1"/>
@@ -450,7 +244,7 @@
         <a:cs typeface="+mn-cs"/>
       </a:defRPr>
     </a:lvl8pPr>
-    <a:lvl9pPr marL="3657600" algn="l" defTabSz="457200" rtl="0" eaLnBrk="1" latinLnBrk="0" hangingPunct="1">
+    <a:lvl9pPr marL="3657600" algn="l" defTabSz="914400" rtl="0" eaLnBrk="1" latinLnBrk="0" hangingPunct="1">
       <a:defRPr sz="1200" kern="1200">
         <a:solidFill>
           <a:schemeClr val="tx1"/>
@@ -465,7 +259,7 @@
 </file>
 
 <file path=ppt/notesSlides/notesSlide1.xml><?xml version="1.0" encoding="utf-8"?>
-<p:notes xmlns:a="http://schemas.openxmlformats.org/drawingml/2006/main" xmlns:p="http://schemas.openxmlformats.org/presentationml/2006/main" xmlns:r="http://schemas.openxmlformats.org/officeDocument/2006/relationships">
+<p:notes xmlns:a="http://schemas.openxmlformats.org/drawingml/2006/main" xmlns:r="http://schemas.openxmlformats.org/officeDocument/2006/relationships" xmlns:p="http://schemas.openxmlformats.org/presentationml/2006/main">
   <p:cSld>
     <p:spTree>
       <p:nvGrpSpPr>
@@ -485,7 +279,7 @@
         <p:nvSpPr>
           <p:cNvPr id="2" name="Slide Image Placeholder 1"/>
           <p:cNvSpPr>
-            <a:spLocks noGrp="1"/>
+            <a:spLocks noGrp="1" noRot="1" noChangeAspect="1"/>
           </p:cNvSpPr>
           <p:nvPr>
             <p:ph type="sldImg" idx="2"/>
@@ -500,7 +294,7 @@
             <a:spLocks noGrp="1"/>
           </p:cNvSpPr>
           <p:nvPr>
-            <p:ph type="body" idx="3" sz="quarter"/>
+            <p:ph type="body" sz="quarter" idx="3"/>
           </p:nvPr>
         </p:nvSpPr>
         <p:spPr/>
@@ -521,7 +315,7 @@
             <a:spLocks noGrp="1"/>
           </p:cNvSpPr>
           <p:nvPr>
-            <p:ph type="sldNum" idx="5" sz="quarter"/>
+            <p:ph type="sldNum" sz="quarter" idx="5"/>
           </p:nvPr>
         </p:nvSpPr>
         <p:spPr/>
@@ -535,7 +329,7 @@
 </file>
 
 <file path=ppt/notesSlides/notesSlide2.xml><?xml version="1.0" encoding="utf-8"?>
-<p:notes xmlns:a="http://schemas.openxmlformats.org/drawingml/2006/main" xmlns:p="http://schemas.openxmlformats.org/presentationml/2006/main" xmlns:r="http://schemas.openxmlformats.org/officeDocument/2006/relationships">
+<p:notes xmlns:a="http://schemas.openxmlformats.org/drawingml/2006/main" xmlns:r="http://schemas.openxmlformats.org/officeDocument/2006/relationships" xmlns:p="http://schemas.openxmlformats.org/presentationml/2006/main">
   <p:cSld>
     <p:spTree>
       <p:nvGrpSpPr>
@@ -555,7 +349,7 @@
         <p:nvSpPr>
           <p:cNvPr id="2" name="Slide Image Placeholder 1"/>
           <p:cNvSpPr>
-            <a:spLocks noGrp="1"/>
+            <a:spLocks noGrp="1" noRot="1" noChangeAspect="1"/>
           </p:cNvSpPr>
           <p:nvPr>
             <p:ph type="sldImg" idx="2"/>
@@ -570,7 +364,7 @@
             <a:spLocks noGrp="1"/>
           </p:cNvSpPr>
           <p:nvPr>
-            <p:ph type="body" idx="3" sz="quarter"/>
+            <p:ph type="body" sz="quarter" idx="3"/>
           </p:nvPr>
         </p:nvSpPr>
         <p:spPr/>
@@ -591,7 +385,7 @@
             <a:spLocks noGrp="1"/>
           </p:cNvSpPr>
           <p:nvPr>
-            <p:ph type="sldNum" idx="5" sz="quarter"/>
+            <p:ph type="sldNum" sz="quarter" idx="5"/>
           </p:nvPr>
         </p:nvSpPr>
         <p:spPr/>
@@ -605,7 +399,7 @@
 </file>
 
 <file path=ppt/notesSlides/notesSlide3.xml><?xml version="1.0" encoding="utf-8"?>
-<p:notes xmlns:a="http://schemas.openxmlformats.org/drawingml/2006/main" xmlns:p="http://schemas.openxmlformats.org/presentationml/2006/main" xmlns:r="http://schemas.openxmlformats.org/officeDocument/2006/relationships">
+<p:notes xmlns:a="http://schemas.openxmlformats.org/drawingml/2006/main" xmlns:r="http://schemas.openxmlformats.org/officeDocument/2006/relationships" xmlns:p="http://schemas.openxmlformats.org/presentationml/2006/main">
   <p:cSld>
     <p:spTree>
       <p:nvGrpSpPr>
@@ -625,7 +419,7 @@
         <p:nvSpPr>
           <p:cNvPr id="2" name="Slide Image Placeholder 1"/>
           <p:cNvSpPr>
-            <a:spLocks noGrp="1"/>
+            <a:spLocks noGrp="1" noRot="1" noChangeAspect="1"/>
           </p:cNvSpPr>
           <p:nvPr>
             <p:ph type="sldImg" idx="2"/>
@@ -640,7 +434,7 @@
             <a:spLocks noGrp="1"/>
           </p:cNvSpPr>
           <p:nvPr>
-            <p:ph type="body" idx="3" sz="quarter"/>
+            <p:ph type="body" sz="quarter" idx="3"/>
           </p:nvPr>
         </p:nvSpPr>
         <p:spPr/>
@@ -661,7 +455,7 @@
             <a:spLocks noGrp="1"/>
           </p:cNvSpPr>
           <p:nvPr>
-            <p:ph type="sldNum" idx="5" sz="quarter"/>
+            <p:ph type="sldNum" sz="quarter" idx="5"/>
           </p:nvPr>
         </p:nvSpPr>
         <p:spPr/>
@@ -675,7 +469,7 @@
 </file>
 
 <file path=ppt/notesSlides/notesSlide4.xml><?xml version="1.0" encoding="utf-8"?>
-<p:notes xmlns:a="http://schemas.openxmlformats.org/drawingml/2006/main" xmlns:p="http://schemas.openxmlformats.org/presentationml/2006/main" xmlns:r="http://schemas.openxmlformats.org/officeDocument/2006/relationships">
+<p:notes xmlns:a="http://schemas.openxmlformats.org/drawingml/2006/main" xmlns:r="http://schemas.openxmlformats.org/officeDocument/2006/relationships" xmlns:p="http://schemas.openxmlformats.org/presentationml/2006/main">
   <p:cSld>
     <p:spTree>
       <p:nvGrpSpPr>
@@ -695,7 +489,7 @@
         <p:nvSpPr>
           <p:cNvPr id="2" name="Slide Image Placeholder 1"/>
           <p:cNvSpPr>
-            <a:spLocks noGrp="1"/>
+            <a:spLocks noGrp="1" noRot="1" noChangeAspect="1"/>
           </p:cNvSpPr>
           <p:nvPr>
             <p:ph type="sldImg" idx="2"/>
@@ -710,7 +504,7 @@
             <a:spLocks noGrp="1"/>
           </p:cNvSpPr>
           <p:nvPr>
-            <p:ph type="body" idx="3" sz="quarter"/>
+            <p:ph type="body" sz="quarter" idx="3"/>
           </p:nvPr>
         </p:nvSpPr>
         <p:spPr/>
@@ -731,7 +525,7 @@
             <a:spLocks noGrp="1"/>
           </p:cNvSpPr>
           <p:nvPr>
-            <p:ph type="sldNum" idx="5" sz="quarter"/>
+            <p:ph type="sldNum" sz="quarter" idx="5"/>
           </p:nvPr>
         </p:nvSpPr>
         <p:spPr/>
@@ -745,7 +539,7 @@
 </file>
 
 <file path=ppt/notesSlides/notesSlide5.xml><?xml version="1.0" encoding="utf-8"?>
-<p:notes xmlns:a="http://schemas.openxmlformats.org/drawingml/2006/main" xmlns:p="http://schemas.openxmlformats.org/presentationml/2006/main" xmlns:r="http://schemas.openxmlformats.org/officeDocument/2006/relationships">
+<p:notes xmlns:a="http://schemas.openxmlformats.org/drawingml/2006/main" xmlns:r="http://schemas.openxmlformats.org/officeDocument/2006/relationships" xmlns:p="http://schemas.openxmlformats.org/presentationml/2006/main">
   <p:cSld>
     <p:spTree>
       <p:nvGrpSpPr>
@@ -765,7 +559,7 @@
         <p:nvSpPr>
           <p:cNvPr id="2" name="Slide Image Placeholder 1"/>
           <p:cNvSpPr>
-            <a:spLocks noGrp="1"/>
+            <a:spLocks noGrp="1" noRot="1" noChangeAspect="1"/>
           </p:cNvSpPr>
           <p:nvPr>
             <p:ph type="sldImg" idx="2"/>
@@ -780,7 +574,7 @@
             <a:spLocks noGrp="1"/>
           </p:cNvSpPr>
           <p:nvPr>
-            <p:ph type="body" idx="3" sz="quarter"/>
+            <p:ph type="body" sz="quarter" idx="3"/>
           </p:nvPr>
         </p:nvSpPr>
         <p:spPr/>
@@ -801,7 +595,7 @@
             <a:spLocks noGrp="1"/>
           </p:cNvSpPr>
           <p:nvPr>
-            <p:ph type="sldNum" idx="5" sz="quarter"/>
+            <p:ph type="sldNum" sz="quarter" idx="5"/>
           </p:nvPr>
         </p:nvSpPr>
         <p:spPr/>
@@ -815,7 +609,7 @@
 </file>
 
 <file path=ppt/notesSlides/notesSlide6.xml><?xml version="1.0" encoding="utf-8"?>
-<p:notes xmlns:a="http://schemas.openxmlformats.org/drawingml/2006/main" xmlns:p="http://schemas.openxmlformats.org/presentationml/2006/main" xmlns:r="http://schemas.openxmlformats.org/officeDocument/2006/relationships">
+<p:notes xmlns:a="http://schemas.openxmlformats.org/drawingml/2006/main" xmlns:r="http://schemas.openxmlformats.org/officeDocument/2006/relationships" xmlns:p="http://schemas.openxmlformats.org/presentationml/2006/main">
   <p:cSld>
     <p:spTree>
       <p:nvGrpSpPr>
@@ -835,7 +629,7 @@
         <p:nvSpPr>
           <p:cNvPr id="2" name="Slide Image Placeholder 1"/>
           <p:cNvSpPr>
-            <a:spLocks noGrp="1"/>
+            <a:spLocks noGrp="1" noRot="1" noChangeAspect="1"/>
           </p:cNvSpPr>
           <p:nvPr>
             <p:ph type="sldImg" idx="2"/>
@@ -850,7 +644,7 @@
             <a:spLocks noGrp="1"/>
           </p:cNvSpPr>
           <p:nvPr>
-            <p:ph type="body" idx="3" sz="quarter"/>
+            <p:ph type="body" sz="quarter" idx="3"/>
           </p:nvPr>
         </p:nvSpPr>
         <p:spPr/>
@@ -871,7 +665,7 @@
             <a:spLocks noGrp="1"/>
           </p:cNvSpPr>
           <p:nvPr>
-            <p:ph type="sldNum" idx="5" sz="quarter"/>
+            <p:ph type="sldNum" sz="quarter" idx="5"/>
           </p:nvPr>
         </p:nvSpPr>
         <p:spPr/>
@@ -885,7 +679,7 @@
 </file>
 
 <file path=ppt/notesSlides/notesSlide7.xml><?xml version="1.0" encoding="utf-8"?>
-<p:notes xmlns:a="http://schemas.openxmlformats.org/drawingml/2006/main" xmlns:p="http://schemas.openxmlformats.org/presentationml/2006/main" xmlns:r="http://schemas.openxmlformats.org/officeDocument/2006/relationships">
+<p:notes xmlns:a="http://schemas.openxmlformats.org/drawingml/2006/main" xmlns:r="http://schemas.openxmlformats.org/officeDocument/2006/relationships" xmlns:p="http://schemas.openxmlformats.org/presentationml/2006/main">
   <p:cSld>
     <p:spTree>
       <p:nvGrpSpPr>
@@ -905,7 +699,7 @@
         <p:nvSpPr>
           <p:cNvPr id="2" name="Slide Image Placeholder 1"/>
           <p:cNvSpPr>
-            <a:spLocks noGrp="1"/>
+            <a:spLocks noGrp="1" noRot="1" noChangeAspect="1"/>
           </p:cNvSpPr>
           <p:nvPr>
             <p:ph type="sldImg" idx="2"/>
@@ -920,7 +714,7 @@
             <a:spLocks noGrp="1"/>
           </p:cNvSpPr>
           <p:nvPr>
-            <p:ph type="body" idx="3" sz="quarter"/>
+            <p:ph type="body" sz="quarter" idx="3"/>
           </p:nvPr>
         </p:nvSpPr>
         <p:spPr/>
@@ -941,7 +735,7 @@
             <a:spLocks noGrp="1"/>
           </p:cNvSpPr>
           <p:nvPr>
-            <p:ph type="sldNum" idx="5" sz="quarter"/>
+            <p:ph type="sldNum" sz="quarter" idx="5"/>
           </p:nvPr>
         </p:nvSpPr>
         <p:spPr/>
@@ -955,7 +749,7 @@
 </file>
 
 <file path=ppt/notesSlides/notesSlide8.xml><?xml version="1.0" encoding="utf-8"?>
-<p:notes xmlns:a="http://schemas.openxmlformats.org/drawingml/2006/main" xmlns:p="http://schemas.openxmlformats.org/presentationml/2006/main" xmlns:r="http://schemas.openxmlformats.org/officeDocument/2006/relationships">
+<p:notes xmlns:a="http://schemas.openxmlformats.org/drawingml/2006/main" xmlns:r="http://schemas.openxmlformats.org/officeDocument/2006/relationships" xmlns:p="http://schemas.openxmlformats.org/presentationml/2006/main">
   <p:cSld>
     <p:spTree>
       <p:nvGrpSpPr>
@@ -975,7 +769,7 @@
         <p:nvSpPr>
           <p:cNvPr id="2" name="Slide Image Placeholder 1"/>
           <p:cNvSpPr>
-            <a:spLocks noGrp="1"/>
+            <a:spLocks noGrp="1" noRot="1" noChangeAspect="1"/>
           </p:cNvSpPr>
           <p:nvPr>
             <p:ph type="sldImg" idx="2"/>
@@ -990,7 +784,7 @@
             <a:spLocks noGrp="1"/>
           </p:cNvSpPr>
           <p:nvPr>
-            <p:ph type="body" idx="3" sz="quarter"/>
+            <p:ph type="body" sz="quarter" idx="3"/>
           </p:nvPr>
         </p:nvSpPr>
         <p:spPr/>
@@ -1011,7 +805,7 @@
             <a:spLocks noGrp="1"/>
           </p:cNvSpPr>
           <p:nvPr>
-            <p:ph type="sldNum" idx="5" sz="quarter"/>
+            <p:ph type="sldNum" sz="quarter" idx="5"/>
           </p:nvPr>
         </p:nvSpPr>
         <p:spPr/>
@@ -1062,10 +856,9 @@
           <a:lstStyle/>
           <a:p>
             <a:r>
-              <a:rPr lang="en-US" smtClean="0"/>
+              <a:rPr lang="en-US"/>
               <a:t>Click to edit Master title style</a:t>
             </a:r>
-            <a:endParaRPr lang="en-US"/>
           </a:p>
         </p:txBody>
       </p:sp>
@@ -1181,10 +974,9 @@
           </a:lstStyle>
           <a:p>
             <a:r>
-              <a:rPr lang="en-US" smtClean="0"/>
+              <a:rPr lang="en-US"/>
               <a:t>Click to edit Master subtitle style</a:t>
             </a:r>
-            <a:endParaRPr lang="en-US"/>
           </a:p>
         </p:txBody>
       </p:sp>
@@ -1205,7 +997,7 @@
           <a:p>
             <a:fld id="{5BCAD085-E8A6-8845-BD4E-CB4CCA059FC4}" type="datetimeFigureOut">
               <a:rPr lang="en-US" smtClean="0"/>
-              <a:t>1/27/13</a:t>
+              <a:t>7/14/2026</a:t>
             </a:fld>
             <a:endParaRPr lang="en-US"/>
           </a:p>
@@ -1299,10 +1091,9 @@
           <a:lstStyle/>
           <a:p>
             <a:r>
-              <a:rPr lang="en-US" smtClean="0"/>
+              <a:rPr lang="en-US"/>
               <a:t>Click to edit Master title style</a:t>
             </a:r>
-            <a:endParaRPr lang="en-US"/>
           </a:p>
         </p:txBody>
       </p:sp>
@@ -1323,38 +1114,37 @@
           <a:p>
             <a:pPr lvl="0"/>
             <a:r>
-              <a:rPr lang="en-US" smtClean="0"/>
+              <a:rPr lang="en-US"/>
               <a:t>Click to edit Master text styles</a:t>
             </a:r>
           </a:p>
           <a:p>
             <a:pPr lvl="1"/>
             <a:r>
-              <a:rPr lang="en-US" smtClean="0"/>
+              <a:rPr lang="en-US"/>
               <a:t>Second level</a:t>
             </a:r>
           </a:p>
           <a:p>
             <a:pPr lvl="2"/>
             <a:r>
-              <a:rPr lang="en-US" smtClean="0"/>
+              <a:rPr lang="en-US"/>
               <a:t>Third level</a:t>
             </a:r>
           </a:p>
           <a:p>
             <a:pPr lvl="3"/>
             <a:r>
-              <a:rPr lang="en-US" smtClean="0"/>
+              <a:rPr lang="en-US"/>
               <a:t>Fourth level</a:t>
             </a:r>
           </a:p>
           <a:p>
             <a:pPr lvl="4"/>
             <a:r>
-              <a:rPr lang="en-US" smtClean="0"/>
+              <a:rPr lang="en-US"/>
               <a:t>Fifth level</a:t>
             </a:r>
-            <a:endParaRPr lang="en-US"/>
           </a:p>
         </p:txBody>
       </p:sp>
@@ -1375,7 +1165,7 @@
           <a:p>
             <a:fld id="{5BCAD085-E8A6-8845-BD4E-CB4CCA059FC4}" type="datetimeFigureOut">
               <a:rPr lang="en-US" smtClean="0"/>
-              <a:t>1/27/13</a:t>
+              <a:t>7/14/2026</a:t>
             </a:fld>
             <a:endParaRPr lang="en-US"/>
           </a:p>
@@ -1474,10 +1264,9 @@
           <a:lstStyle/>
           <a:p>
             <a:r>
-              <a:rPr lang="en-US" smtClean="0"/>
+              <a:rPr lang="en-US"/>
               <a:t>Click to edit Master title style</a:t>
             </a:r>
-            <a:endParaRPr lang="en-US"/>
           </a:p>
         </p:txBody>
       </p:sp>
@@ -1503,38 +1292,37 @@
           <a:p>
             <a:pPr lvl="0"/>
             <a:r>
-              <a:rPr lang="en-US" smtClean="0"/>
+              <a:rPr lang="en-US"/>
               <a:t>Click to edit Master text styles</a:t>
             </a:r>
           </a:p>
           <a:p>
             <a:pPr lvl="1"/>
             <a:r>
-              <a:rPr lang="en-US" smtClean="0"/>
+              <a:rPr lang="en-US"/>
               <a:t>Second level</a:t>
             </a:r>
           </a:p>
           <a:p>
             <a:pPr lvl="2"/>
             <a:r>
-              <a:rPr lang="en-US" smtClean="0"/>
+              <a:rPr lang="en-US"/>
               <a:t>Third level</a:t>
             </a:r>
           </a:p>
           <a:p>
             <a:pPr lvl="3"/>
             <a:r>
-              <a:rPr lang="en-US" smtClean="0"/>
+              <a:rPr lang="en-US"/>
               <a:t>Fourth level</a:t>
             </a:r>
           </a:p>
           <a:p>
             <a:pPr lvl="4"/>
             <a:r>
-              <a:rPr lang="en-US" smtClean="0"/>
+              <a:rPr lang="en-US"/>
               <a:t>Fifth level</a:t>
             </a:r>
-            <a:endParaRPr lang="en-US"/>
           </a:p>
         </p:txBody>
       </p:sp>
@@ -1555,7 +1343,7 @@
           <a:p>
             <a:fld id="{5BCAD085-E8A6-8845-BD4E-CB4CCA059FC4}" type="datetimeFigureOut">
               <a:rPr lang="en-US" smtClean="0"/>
-              <a:t>1/27/13</a:t>
+              <a:t>7/14/2026</a:t>
             </a:fld>
             <a:endParaRPr lang="en-US"/>
           </a:p>
@@ -1649,10 +1437,9 @@
           <a:lstStyle/>
           <a:p>
             <a:r>
-              <a:rPr lang="en-US" smtClean="0"/>
+              <a:rPr lang="en-US"/>
               <a:t>Click to edit Master title style</a:t>
             </a:r>
-            <a:endParaRPr lang="en-US"/>
           </a:p>
         </p:txBody>
       </p:sp>
@@ -1673,38 +1460,37 @@
           <a:p>
             <a:pPr lvl="0"/>
             <a:r>
-              <a:rPr lang="en-US" smtClean="0"/>
+              <a:rPr lang="en-US"/>
               <a:t>Click to edit Master text styles</a:t>
             </a:r>
           </a:p>
           <a:p>
             <a:pPr lvl="1"/>
             <a:r>
-              <a:rPr lang="en-US" smtClean="0"/>
+              <a:rPr lang="en-US"/>
               <a:t>Second level</a:t>
             </a:r>
           </a:p>
           <a:p>
             <a:pPr lvl="2"/>
             <a:r>
-              <a:rPr lang="en-US" smtClean="0"/>
+              <a:rPr lang="en-US"/>
               <a:t>Third level</a:t>
             </a:r>
           </a:p>
           <a:p>
             <a:pPr lvl="3"/>
             <a:r>
-              <a:rPr lang="en-US" smtClean="0"/>
+              <a:rPr lang="en-US"/>
               <a:t>Fourth level</a:t>
             </a:r>
           </a:p>
           <a:p>
             <a:pPr lvl="4"/>
             <a:r>
-              <a:rPr lang="en-US" smtClean="0"/>
+              <a:rPr lang="en-US"/>
               <a:t>Fifth level</a:t>
             </a:r>
-            <a:endParaRPr lang="en-US"/>
           </a:p>
         </p:txBody>
       </p:sp>
@@ -1725,7 +1511,7 @@
           <a:p>
             <a:fld id="{5BCAD085-E8A6-8845-BD4E-CB4CCA059FC4}" type="datetimeFigureOut">
               <a:rPr lang="en-US" smtClean="0"/>
-              <a:t>1/27/13</a:t>
+              <a:t>7/14/2026</a:t>
             </a:fld>
             <a:endParaRPr lang="en-US"/>
           </a:p>
@@ -1828,10 +1614,9 @@
           </a:lstStyle>
           <a:p>
             <a:r>
-              <a:rPr lang="en-US" smtClean="0"/>
+              <a:rPr lang="en-US"/>
               <a:t>Click to edit Master title style</a:t>
             </a:r>
-            <a:endParaRPr lang="en-US"/>
           </a:p>
         </p:txBody>
       </p:sp>
@@ -1948,7 +1733,7 @@
           <a:p>
             <a:pPr lvl="0"/>
             <a:r>
-              <a:rPr lang="en-US" smtClean="0"/>
+              <a:rPr lang="en-US"/>
               <a:t>Click to edit Master text styles</a:t>
             </a:r>
           </a:p>
@@ -1971,7 +1756,7 @@
           <a:p>
             <a:fld id="{5BCAD085-E8A6-8845-BD4E-CB4CCA059FC4}" type="datetimeFigureOut">
               <a:rPr lang="en-US" smtClean="0"/>
-              <a:t>1/27/13</a:t>
+              <a:t>7/14/2026</a:t>
             </a:fld>
             <a:endParaRPr lang="en-US"/>
           </a:p>
@@ -2065,10 +1850,9 @@
           <a:lstStyle/>
           <a:p>
             <a:r>
-              <a:rPr lang="en-US" smtClean="0"/>
+              <a:rPr lang="en-US"/>
               <a:t>Click to edit Master title style</a:t>
             </a:r>
-            <a:endParaRPr lang="en-US"/>
           </a:p>
         </p:txBody>
       </p:sp>
@@ -2122,38 +1906,37 @@
           <a:p>
             <a:pPr lvl="0"/>
             <a:r>
-              <a:rPr lang="en-US" smtClean="0"/>
+              <a:rPr lang="en-US"/>
               <a:t>Click to edit Master text styles</a:t>
             </a:r>
           </a:p>
           <a:p>
             <a:pPr lvl="1"/>
             <a:r>
-              <a:rPr lang="en-US" smtClean="0"/>
+              <a:rPr lang="en-US"/>
               <a:t>Second level</a:t>
             </a:r>
           </a:p>
           <a:p>
             <a:pPr lvl="2"/>
             <a:r>
-              <a:rPr lang="en-US" smtClean="0"/>
+              <a:rPr lang="en-US"/>
               <a:t>Third level</a:t>
             </a:r>
           </a:p>
           <a:p>
             <a:pPr lvl="3"/>
             <a:r>
-              <a:rPr lang="en-US" smtClean="0"/>
+              <a:rPr lang="en-US"/>
               <a:t>Fourth level</a:t>
             </a:r>
           </a:p>
           <a:p>
             <a:pPr lvl="4"/>
             <a:r>
-              <a:rPr lang="en-US" smtClean="0"/>
+              <a:rPr lang="en-US"/>
               <a:t>Fifth level</a:t>
             </a:r>
-            <a:endParaRPr lang="en-US"/>
           </a:p>
         </p:txBody>
       </p:sp>
@@ -2207,38 +1990,37 @@
           <a:p>
             <a:pPr lvl="0"/>
             <a:r>
-              <a:rPr lang="en-US" smtClean="0"/>
+              <a:rPr lang="en-US"/>
               <a:t>Click to edit Master text styles</a:t>
             </a:r>
           </a:p>
           <a:p>
             <a:pPr lvl="1"/>
             <a:r>
-              <a:rPr lang="en-US" smtClean="0"/>
+              <a:rPr lang="en-US"/>
               <a:t>Second level</a:t>
             </a:r>
           </a:p>
           <a:p>
             <a:pPr lvl="2"/>
             <a:r>
-              <a:rPr lang="en-US" smtClean="0"/>
+              <a:rPr lang="en-US"/>
               <a:t>Third level</a:t>
             </a:r>
           </a:p>
           <a:p>
             <a:pPr lvl="3"/>
             <a:r>
-              <a:rPr lang="en-US" smtClean="0"/>
+              <a:rPr lang="en-US"/>
               <a:t>Fourth level</a:t>
             </a:r>
           </a:p>
           <a:p>
             <a:pPr lvl="4"/>
             <a:r>
-              <a:rPr lang="en-US" smtClean="0"/>
+              <a:rPr lang="en-US"/>
               <a:t>Fifth level</a:t>
             </a:r>
-            <a:endParaRPr lang="en-US"/>
           </a:p>
         </p:txBody>
       </p:sp>
@@ -2259,7 +2041,7 @@
           <a:p>
             <a:fld id="{5BCAD085-E8A6-8845-BD4E-CB4CCA059FC4}" type="datetimeFigureOut">
               <a:rPr lang="en-US" smtClean="0"/>
-              <a:t>1/27/13</a:t>
+              <a:t>7/14/2026</a:t>
             </a:fld>
             <a:endParaRPr lang="en-US"/>
           </a:p>
@@ -2357,10 +2139,9 @@
           </a:lstStyle>
           <a:p>
             <a:r>
-              <a:rPr lang="en-US" smtClean="0"/>
+              <a:rPr lang="en-US"/>
               <a:t>Click to edit Master title style</a:t>
             </a:r>
-            <a:endParaRPr lang="en-US"/>
           </a:p>
         </p:txBody>
       </p:sp>
@@ -2423,7 +2204,7 @@
           <a:p>
             <a:pPr lvl="0"/>
             <a:r>
-              <a:rPr lang="en-US" smtClean="0"/>
+              <a:rPr lang="en-US"/>
               <a:t>Click to edit Master text styles</a:t>
             </a:r>
           </a:p>
@@ -2479,38 +2260,37 @@
           <a:p>
             <a:pPr lvl="0"/>
             <a:r>
-              <a:rPr lang="en-US" smtClean="0"/>
+              <a:rPr lang="en-US"/>
               <a:t>Click to edit Master text styles</a:t>
             </a:r>
           </a:p>
           <a:p>
             <a:pPr lvl="1"/>
             <a:r>
-              <a:rPr lang="en-US" smtClean="0"/>
+              <a:rPr lang="en-US"/>
               <a:t>Second level</a:t>
             </a:r>
           </a:p>
           <a:p>
             <a:pPr lvl="2"/>
             <a:r>
-              <a:rPr lang="en-US" smtClean="0"/>
+              <a:rPr lang="en-US"/>
               <a:t>Third level</a:t>
             </a:r>
           </a:p>
           <a:p>
             <a:pPr lvl="3"/>
             <a:r>
-              <a:rPr lang="en-US" smtClean="0"/>
+              <a:rPr lang="en-US"/>
               <a:t>Fourth level</a:t>
             </a:r>
           </a:p>
           <a:p>
             <a:pPr lvl="4"/>
             <a:r>
-              <a:rPr lang="en-US" smtClean="0"/>
+              <a:rPr lang="en-US"/>
               <a:t>Fifth level</a:t>
             </a:r>
-            <a:endParaRPr lang="en-US"/>
           </a:p>
         </p:txBody>
       </p:sp>
@@ -2573,7 +2353,7 @@
           <a:p>
             <a:pPr lvl="0"/>
             <a:r>
-              <a:rPr lang="en-US" smtClean="0"/>
+              <a:rPr lang="en-US"/>
               <a:t>Click to edit Master text styles</a:t>
             </a:r>
           </a:p>
@@ -2629,38 +2409,37 @@
           <a:p>
             <a:pPr lvl="0"/>
             <a:r>
-              <a:rPr lang="en-US" smtClean="0"/>
+              <a:rPr lang="en-US"/>
               <a:t>Click to edit Master text styles</a:t>
             </a:r>
           </a:p>
           <a:p>
             <a:pPr lvl="1"/>
             <a:r>
-              <a:rPr lang="en-US" smtClean="0"/>
+              <a:rPr lang="en-US"/>
               <a:t>Second level</a:t>
             </a:r>
           </a:p>
           <a:p>
             <a:pPr lvl="2"/>
             <a:r>
-              <a:rPr lang="en-US" smtClean="0"/>
+              <a:rPr lang="en-US"/>
               <a:t>Third level</a:t>
             </a:r>
           </a:p>
           <a:p>
             <a:pPr lvl="3"/>
             <a:r>
-              <a:rPr lang="en-US" smtClean="0"/>
+              <a:rPr lang="en-US"/>
               <a:t>Fourth level</a:t>
             </a:r>
           </a:p>
           <a:p>
             <a:pPr lvl="4"/>
             <a:r>
-              <a:rPr lang="en-US" smtClean="0"/>
+              <a:rPr lang="en-US"/>
               <a:t>Fifth level</a:t>
             </a:r>
-            <a:endParaRPr lang="en-US"/>
           </a:p>
         </p:txBody>
       </p:sp>
@@ -2681,7 +2460,7 @@
           <a:p>
             <a:fld id="{5BCAD085-E8A6-8845-BD4E-CB4CCA059FC4}" type="datetimeFigureOut">
               <a:rPr lang="en-US" smtClean="0"/>
-              <a:t>1/27/13</a:t>
+              <a:t>7/14/2026</a:t>
             </a:fld>
             <a:endParaRPr lang="en-US"/>
           </a:p>
@@ -2775,10 +2554,9 @@
           <a:lstStyle/>
           <a:p>
             <a:r>
-              <a:rPr lang="en-US" smtClean="0"/>
+              <a:rPr lang="en-US"/>
               <a:t>Click to edit Master title style</a:t>
             </a:r>
-            <a:endParaRPr lang="en-US"/>
           </a:p>
         </p:txBody>
       </p:sp>
@@ -2799,7 +2577,7 @@
           <a:p>
             <a:fld id="{5BCAD085-E8A6-8845-BD4E-CB4CCA059FC4}" type="datetimeFigureOut">
               <a:rPr lang="en-US" smtClean="0"/>
-              <a:t>1/27/13</a:t>
+              <a:t>7/14/2026</a:t>
             </a:fld>
             <a:endParaRPr lang="en-US"/>
           </a:p>
@@ -2894,7 +2672,7 @@
           <a:p>
             <a:fld id="{5BCAD085-E8A6-8845-BD4E-CB4CCA059FC4}" type="datetimeFigureOut">
               <a:rPr lang="en-US" smtClean="0"/>
-              <a:t>1/27/13</a:t>
+              <a:t>7/14/2026</a:t>
             </a:fld>
             <a:endParaRPr lang="en-US"/>
           </a:p>
@@ -2997,10 +2775,9 @@
           </a:lstStyle>
           <a:p>
             <a:r>
-              <a:rPr lang="en-US" smtClean="0"/>
+              <a:rPr lang="en-US"/>
               <a:t>Click to edit Master title style</a:t>
             </a:r>
-            <a:endParaRPr lang="en-US"/>
           </a:p>
         </p:txBody>
       </p:sp>
@@ -3054,38 +2831,37 @@
           <a:p>
             <a:pPr lvl="0"/>
             <a:r>
-              <a:rPr lang="en-US" smtClean="0"/>
+              <a:rPr lang="en-US"/>
               <a:t>Click to edit Master text styles</a:t>
             </a:r>
           </a:p>
           <a:p>
             <a:pPr lvl="1"/>
             <a:r>
-              <a:rPr lang="en-US" smtClean="0"/>
+              <a:rPr lang="en-US"/>
               <a:t>Second level</a:t>
             </a:r>
           </a:p>
           <a:p>
             <a:pPr lvl="2"/>
             <a:r>
-              <a:rPr lang="en-US" smtClean="0"/>
+              <a:rPr lang="en-US"/>
               <a:t>Third level</a:t>
             </a:r>
           </a:p>
           <a:p>
             <a:pPr lvl="3"/>
             <a:r>
-              <a:rPr lang="en-US" smtClean="0"/>
+              <a:rPr lang="en-US"/>
               <a:t>Fourth level</a:t>
             </a:r>
           </a:p>
           <a:p>
             <a:pPr lvl="4"/>
             <a:r>
-              <a:rPr lang="en-US" smtClean="0"/>
+              <a:rPr lang="en-US"/>
               <a:t>Fifth level</a:t>
             </a:r>
-            <a:endParaRPr lang="en-US"/>
           </a:p>
         </p:txBody>
       </p:sp>
@@ -3148,7 +2924,7 @@
           <a:p>
             <a:pPr lvl="0"/>
             <a:r>
-              <a:rPr lang="en-US" smtClean="0"/>
+              <a:rPr lang="en-US"/>
               <a:t>Click to edit Master text styles</a:t>
             </a:r>
           </a:p>
@@ -3171,7 +2947,7 @@
           <a:p>
             <a:fld id="{5BCAD085-E8A6-8845-BD4E-CB4CCA059FC4}" type="datetimeFigureOut">
               <a:rPr lang="en-US" smtClean="0"/>
-              <a:t>1/27/13</a:t>
+              <a:t>7/14/2026</a:t>
             </a:fld>
             <a:endParaRPr lang="en-US"/>
           </a:p>
@@ -3274,10 +3050,9 @@
           </a:lstStyle>
           <a:p>
             <a:r>
-              <a:rPr lang="en-US" smtClean="0"/>
+              <a:rPr lang="en-US"/>
               <a:t>Click to edit Master title style</a:t>
             </a:r>
-            <a:endParaRPr lang="en-US"/>
           </a:p>
         </p:txBody>
       </p:sp>
@@ -3401,7 +3176,7 @@
           <a:p>
             <a:pPr lvl="0"/>
             <a:r>
-              <a:rPr lang="en-US" smtClean="0"/>
+              <a:rPr lang="en-US"/>
               <a:t>Click to edit Master text styles</a:t>
             </a:r>
           </a:p>
@@ -3424,7 +3199,7 @@
           <a:p>
             <a:fld id="{5BCAD085-E8A6-8845-BD4E-CB4CCA059FC4}" type="datetimeFigureOut">
               <a:rPr lang="en-US" smtClean="0"/>
-              <a:t>1/27/13</a:t>
+              <a:t>7/14/2026</a:t>
             </a:fld>
             <a:endParaRPr lang="en-US"/>
           </a:p>
@@ -3533,10 +3308,9 @@
           <a:lstStyle/>
           <a:p>
             <a:r>
-              <a:rPr lang="en-US" smtClean="0"/>
+              <a:rPr lang="en-US"/>
               <a:t>Click to edit Master title style</a:t>
             </a:r>
-            <a:endParaRPr lang="en-US"/>
           </a:p>
         </p:txBody>
       </p:sp>
@@ -3567,38 +3341,37 @@
           <a:p>
             <a:pPr lvl="0"/>
             <a:r>
-              <a:rPr lang="en-US" smtClean="0"/>
+              <a:rPr lang="en-US"/>
               <a:t>Click to edit Master text styles</a:t>
             </a:r>
           </a:p>
           <a:p>
             <a:pPr lvl="1"/>
             <a:r>
-              <a:rPr lang="en-US" smtClean="0"/>
+              <a:rPr lang="en-US"/>
               <a:t>Second level</a:t>
             </a:r>
           </a:p>
           <a:p>
             <a:pPr lvl="2"/>
             <a:r>
-              <a:rPr lang="en-US" smtClean="0"/>
+              <a:rPr lang="en-US"/>
               <a:t>Third level</a:t>
             </a:r>
           </a:p>
           <a:p>
             <a:pPr lvl="3"/>
             <a:r>
-              <a:rPr lang="en-US" smtClean="0"/>
+              <a:rPr lang="en-US"/>
               <a:t>Fourth level</a:t>
             </a:r>
           </a:p>
           <a:p>
             <a:pPr lvl="4"/>
             <a:r>
-              <a:rPr lang="en-US" smtClean="0"/>
+              <a:rPr lang="en-US"/>
               <a:t>Fifth level</a:t>
             </a:r>
-            <a:endParaRPr lang="en-US"/>
           </a:p>
         </p:txBody>
       </p:sp>
@@ -3637,7 +3410,7 @@
           <a:p>
             <a:fld id="{5BCAD085-E8A6-8845-BD4E-CB4CCA059FC4}" type="datetimeFigureOut">
               <a:rPr lang="en-US" smtClean="0"/>
-              <a:t>1/27/13</a:t>
+              <a:t>7/14/2026</a:t>
             </a:fld>
             <a:endParaRPr lang="en-US"/>
           </a:p>
@@ -3996,7 +3769,7 @@
 </file>
 
 <file path=ppt/slides/slide1.xml><?xml version="1.0" encoding="utf-8"?>
-<p:sld xmlns:a="http://schemas.openxmlformats.org/drawingml/2006/main" xmlns:p="http://schemas.openxmlformats.org/presentationml/2006/main" xmlns:r="http://schemas.openxmlformats.org/officeDocument/2006/relationships">
+<p:sld xmlns:a="http://schemas.openxmlformats.org/drawingml/2006/main" xmlns:r="http://schemas.openxmlformats.org/officeDocument/2006/relationships" xmlns:p="http://schemas.openxmlformats.org/presentationml/2006/main">
   <p:cSld>
     <p:spTree>
       <p:nvGrpSpPr>
@@ -4004,7 +3777,14 @@
         <p:cNvGrpSpPr/>
         <p:nvPr/>
       </p:nvGrpSpPr>
-      <p:grpSpPr/>
+      <p:grpSpPr>
+        <a:xfrm>
+          <a:off x="0" y="0"/>
+          <a:ext cx="0" cy="0"/>
+          <a:chOff x="0" y="0"/>
+          <a:chExt cx="0" cy="0"/>
+        </a:xfrm>
+      </p:grpSpPr>
       <p:sp>
         <p:nvSpPr>
           <p:cNvPr id="2" name="TextBox 1"/>
@@ -4022,7 +3802,7 @@
           <a:noFill/>
         </p:spPr>
         <p:txBody>
-          <a:bodyPr wrap="square" lIns="0" rIns="0" tIns="0" bIns="0" anchor="t">
+          <a:bodyPr wrap="square" lIns="0" tIns="0" rIns="0" bIns="0" anchor="t">
             <a:spAutoFit/>
           </a:bodyPr>
           <a:lstStyle/>
@@ -4068,7 +3848,7 @@
           <a:noFill/>
         </p:spPr>
         <p:txBody>
-          <a:bodyPr wrap="square" lIns="0" rIns="0" tIns="0" bIns="0" anchor="t">
+          <a:bodyPr wrap="square" lIns="0" tIns="0" rIns="0" bIns="0" anchor="t">
             <a:spAutoFit/>
           </a:bodyPr>
           <a:lstStyle/>
@@ -4137,7 +3917,7 @@
           <a:noFill/>
         </p:spPr>
         <p:txBody>
-          <a:bodyPr wrap="square" lIns="0" rIns="0" tIns="0" bIns="0" anchor="t">
+          <a:bodyPr wrap="square" lIns="0" tIns="0" rIns="0" bIns="0" anchor="t">
             <a:spAutoFit/>
           </a:bodyPr>
           <a:lstStyle/>
@@ -4183,7 +3963,7 @@
           <a:noFill/>
         </p:spPr>
         <p:txBody>
-          <a:bodyPr wrap="square" lIns="0" rIns="0" tIns="0" bIns="0" anchor="t">
+          <a:bodyPr wrap="square" lIns="0" tIns="0" rIns="0" bIns="0" anchor="t">
             <a:spAutoFit/>
           </a:bodyPr>
           <a:lstStyle/>
@@ -4256,7 +4036,7 @@
           <a:noFill/>
         </p:spPr>
         <p:txBody>
-          <a:bodyPr wrap="square" lIns="0" rIns="0" tIns="0" bIns="0" anchor="t">
+          <a:bodyPr wrap="square" lIns="0" tIns="0" rIns="0" bIns="0" anchor="t">
             <a:spAutoFit/>
           </a:bodyPr>
           <a:lstStyle/>
@@ -4336,6 +4116,7 @@
           <a:lstStyle/>
           <a:p>
             <a:pPr algn="ctr"/>
+            <a:endParaRPr/>
           </a:p>
         </p:txBody>
       </p:sp>
@@ -4356,7 +4137,7 @@
           <a:noFill/>
         </p:spPr>
         <p:txBody>
-          <a:bodyPr wrap="square" lIns="0" rIns="0" tIns="0" bIns="0" anchor="t">
+          <a:bodyPr wrap="square" lIns="0" tIns="0" rIns="0" bIns="0" anchor="t">
             <a:spAutoFit/>
           </a:bodyPr>
           <a:lstStyle/>
@@ -4409,7 +4190,7 @@
           <a:noFill/>
         </p:spPr>
         <p:txBody>
-          <a:bodyPr wrap="square" lIns="0" rIns="0" tIns="0" bIns="0" anchor="t">
+          <a:bodyPr wrap="square" lIns="0" tIns="0" rIns="0" bIns="0" anchor="t">
             <a:spAutoFit/>
           </a:bodyPr>
           <a:lstStyle/>
@@ -4482,6 +4263,7 @@
           <a:lstStyle/>
           <a:p>
             <a:pPr algn="ctr"/>
+            <a:endParaRPr/>
           </a:p>
         </p:txBody>
       </p:sp>
@@ -4494,7 +4276,7 @@
           <p:nvPr/>
         </p:nvPicPr>
         <p:blipFill>
-          <a:blip r:embed="rId2"/>
+          <a:blip r:embed="rId3"/>
           <a:stretch>
             <a:fillRect/>
           </a:stretch>
@@ -4526,7 +4308,7 @@
           <a:noFill/>
         </p:spPr>
         <p:txBody>
-          <a:bodyPr wrap="square" lIns="0" rIns="0" tIns="0" bIns="0" anchor="t">
+          <a:bodyPr wrap="square" lIns="0" tIns="0" rIns="0" bIns="0" anchor="t">
             <a:spAutoFit/>
           </a:bodyPr>
           <a:lstStyle/>
@@ -4599,6 +4381,7 @@
           <a:lstStyle/>
           <a:p>
             <a:pPr algn="ctr"/>
+            <a:endParaRPr/>
           </a:p>
         </p:txBody>
       </p:sp>
@@ -4611,7 +4394,7 @@
           <p:nvPr/>
         </p:nvPicPr>
         <p:blipFill>
-          <a:blip r:embed="rId3"/>
+          <a:blip r:embed="rId4"/>
           <a:srcRect b="48000"/>
           <a:stretch>
             <a:fillRect/>
@@ -4644,7 +4427,7 @@
           <a:noFill/>
         </p:spPr>
         <p:txBody>
-          <a:bodyPr wrap="square" lIns="0" rIns="0" tIns="0" bIns="0" anchor="t">
+          <a:bodyPr wrap="square" lIns="0" tIns="0" rIns="0" bIns="0" anchor="t">
             <a:spAutoFit/>
           </a:bodyPr>
           <a:lstStyle/>
@@ -4725,7 +4508,7 @@
           <a:noFill/>
         </p:spPr>
         <p:txBody>
-          <a:bodyPr wrap="square" lIns="0" rIns="0" tIns="0" bIns="0" anchor="t">
+          <a:bodyPr wrap="square" lIns="0" tIns="0" rIns="0" bIns="0" anchor="t">
             <a:spAutoFit/>
           </a:bodyPr>
           <a:lstStyle/>
@@ -4771,7 +4554,7 @@
           <a:noFill/>
         </p:spPr>
         <p:txBody>
-          <a:bodyPr wrap="square" lIns="0" rIns="0" tIns="0" bIns="0" anchor="t">
+          <a:bodyPr wrap="square" lIns="0" tIns="0" rIns="0" bIns="0" anchor="t">
             <a:spAutoFit/>
           </a:bodyPr>
           <a:lstStyle/>
@@ -4817,7 +4600,7 @@
           <a:noFill/>
         </p:spPr>
         <p:txBody>
-          <a:bodyPr wrap="square" lIns="0" rIns="0" tIns="0" bIns="0" anchor="t">
+          <a:bodyPr wrap="square" lIns="0" tIns="0" rIns="0" bIns="0" anchor="t">
             <a:spAutoFit/>
           </a:bodyPr>
           <a:lstStyle/>
@@ -4855,7 +4638,7 @@
 </file>
 
 <file path=ppt/slides/slide2.xml><?xml version="1.0" encoding="utf-8"?>
-<p:sld xmlns:a="http://schemas.openxmlformats.org/drawingml/2006/main" xmlns:p="http://schemas.openxmlformats.org/presentationml/2006/main" xmlns:r="http://schemas.openxmlformats.org/officeDocument/2006/relationships">
+<p:sld xmlns:a="http://schemas.openxmlformats.org/drawingml/2006/main" xmlns:r="http://schemas.openxmlformats.org/officeDocument/2006/relationships" xmlns:p="http://schemas.openxmlformats.org/presentationml/2006/main">
   <p:cSld>
     <p:spTree>
       <p:nvGrpSpPr>
@@ -4863,7 +4646,14 @@
         <p:cNvGrpSpPr/>
         <p:nvPr/>
       </p:nvGrpSpPr>
-      <p:grpSpPr/>
+      <p:grpSpPr>
+        <a:xfrm>
+          <a:off x="0" y="0"/>
+          <a:ext cx="0" cy="0"/>
+          <a:chOff x="0" y="0"/>
+          <a:chExt cx="0" cy="0"/>
+        </a:xfrm>
+      </p:grpSpPr>
       <p:sp>
         <p:nvSpPr>
           <p:cNvPr id="2" name="TextBox 1"/>
@@ -4881,7 +4671,7 @@
           <a:noFill/>
         </p:spPr>
         <p:txBody>
-          <a:bodyPr wrap="square" lIns="0" rIns="0" tIns="0" bIns="0" anchor="t">
+          <a:bodyPr wrap="square" lIns="0" tIns="0" rIns="0" bIns="0" anchor="t">
             <a:spAutoFit/>
           </a:bodyPr>
           <a:lstStyle/>
@@ -4927,7 +4717,7 @@
           <a:noFill/>
         </p:spPr>
         <p:txBody>
-          <a:bodyPr wrap="square" lIns="0" rIns="0" tIns="0" bIns="0" anchor="ctr">
+          <a:bodyPr wrap="square" lIns="0" tIns="0" rIns="0" bIns="0" anchor="ctr">
             <a:spAutoFit/>
           </a:bodyPr>
           <a:lstStyle/>
@@ -5043,7 +4833,7 @@
           <a:noFill/>
         </p:spPr>
         <p:txBody>
-          <a:bodyPr wrap="square" lIns="0" rIns="0" tIns="0" bIns="0" anchor="t">
+          <a:bodyPr wrap="square" lIns="0" tIns="0" rIns="0" bIns="0" anchor="t">
             <a:spAutoFit/>
           </a:bodyPr>
           <a:lstStyle/>
@@ -5089,7 +4879,7 @@
           <a:noFill/>
         </p:spPr>
         <p:txBody>
-          <a:bodyPr wrap="square" lIns="0" rIns="0" tIns="0" bIns="0" anchor="t">
+          <a:bodyPr wrap="square" lIns="0" tIns="0" rIns="0" bIns="0" anchor="t">
             <a:spAutoFit/>
           </a:bodyPr>
           <a:lstStyle/>
@@ -5135,7 +4925,7 @@
           <a:noFill/>
         </p:spPr>
         <p:txBody>
-          <a:bodyPr wrap="square" lIns="0" rIns="0" tIns="0" bIns="0" anchor="t">
+          <a:bodyPr wrap="square" lIns="0" tIns="0" rIns="0" bIns="0" anchor="t">
             <a:spAutoFit/>
           </a:bodyPr>
           <a:lstStyle/>
@@ -5208,6 +4998,7 @@
           <a:lstStyle/>
           <a:p>
             <a:pPr algn="ctr"/>
+            <a:endParaRPr/>
           </a:p>
         </p:txBody>
       </p:sp>
@@ -5228,7 +5019,7 @@
           <a:noFill/>
         </p:spPr>
         <p:txBody>
-          <a:bodyPr wrap="square" lIns="0" rIns="0" tIns="0" bIns="0" anchor="t">
+          <a:bodyPr wrap="square" lIns="0" tIns="0" rIns="0" bIns="0" anchor="t">
             <a:spAutoFit/>
           </a:bodyPr>
           <a:lstStyle/>
@@ -5274,7 +5065,7 @@
           <a:noFill/>
         </p:spPr>
         <p:txBody>
-          <a:bodyPr wrap="square" lIns="0" rIns="0" tIns="0" bIns="0" anchor="t">
+          <a:bodyPr wrap="square" lIns="0" tIns="0" rIns="0" bIns="0" anchor="t">
             <a:spAutoFit/>
           </a:bodyPr>
           <a:lstStyle/>
@@ -5355,7 +5146,7 @@
           <a:noFill/>
         </p:spPr>
         <p:txBody>
-          <a:bodyPr wrap="square" lIns="0" rIns="0" tIns="0" bIns="0" anchor="t">
+          <a:bodyPr wrap="square" lIns="0" tIns="0" rIns="0" bIns="0" anchor="t">
             <a:spAutoFit/>
           </a:bodyPr>
           <a:lstStyle/>
@@ -5451,6 +5242,7 @@
           <a:lstStyle/>
           <a:p>
             <a:pPr algn="ctr"/>
+            <a:endParaRPr/>
           </a:p>
         </p:txBody>
       </p:sp>
@@ -5471,7 +5263,7 @@
           <a:noFill/>
         </p:spPr>
         <p:txBody>
-          <a:bodyPr wrap="square" lIns="0" rIns="0" tIns="0" bIns="0" anchor="t">
+          <a:bodyPr wrap="square" lIns="0" tIns="0" rIns="0" bIns="0" anchor="t">
             <a:spAutoFit/>
           </a:bodyPr>
           <a:lstStyle/>
@@ -5517,7 +5309,7 @@
           <a:noFill/>
         </p:spPr>
         <p:txBody>
-          <a:bodyPr wrap="square" lIns="0" rIns="0" tIns="0" bIns="0" anchor="t">
+          <a:bodyPr wrap="square" lIns="0" tIns="0" rIns="0" bIns="0" anchor="t">
             <a:spAutoFit/>
           </a:bodyPr>
           <a:lstStyle/>
@@ -5598,7 +5390,7 @@
           <a:noFill/>
         </p:spPr>
         <p:txBody>
-          <a:bodyPr wrap="square" lIns="0" rIns="0" tIns="0" bIns="0" anchor="t">
+          <a:bodyPr wrap="square" lIns="0" tIns="0" rIns="0" bIns="0" anchor="t">
             <a:spAutoFit/>
           </a:bodyPr>
           <a:lstStyle/>
@@ -5694,6 +5486,7 @@
           <a:lstStyle/>
           <a:p>
             <a:pPr algn="ctr"/>
+            <a:endParaRPr/>
           </a:p>
         </p:txBody>
       </p:sp>
@@ -5714,7 +5507,7 @@
           <a:noFill/>
         </p:spPr>
         <p:txBody>
-          <a:bodyPr wrap="square" lIns="0" rIns="0" tIns="0" bIns="0" anchor="t">
+          <a:bodyPr wrap="square" lIns="0" tIns="0" rIns="0" bIns="0" anchor="t">
             <a:spAutoFit/>
           </a:bodyPr>
           <a:lstStyle/>
@@ -5760,7 +5553,7 @@
           <a:noFill/>
         </p:spPr>
         <p:txBody>
-          <a:bodyPr wrap="square" lIns="0" rIns="0" tIns="0" bIns="0" anchor="t">
+          <a:bodyPr wrap="square" lIns="0" tIns="0" rIns="0" bIns="0" anchor="t">
             <a:spAutoFit/>
           </a:bodyPr>
           <a:lstStyle/>
@@ -5841,7 +5634,7 @@
           <a:noFill/>
         </p:spPr>
         <p:txBody>
-          <a:bodyPr wrap="square" lIns="0" rIns="0" tIns="0" bIns="0" anchor="t">
+          <a:bodyPr wrap="square" lIns="0" tIns="0" rIns="0" bIns="0" anchor="t">
             <a:spAutoFit/>
           </a:bodyPr>
           <a:lstStyle/>
@@ -5910,7 +5703,7 @@
           <a:noFill/>
         </p:spPr>
         <p:txBody>
-          <a:bodyPr wrap="square" lIns="0" rIns="0" tIns="0" bIns="0" anchor="t">
+          <a:bodyPr wrap="square" lIns="0" tIns="0" rIns="0" bIns="0" anchor="t">
             <a:spAutoFit/>
           </a:bodyPr>
           <a:lstStyle/>
@@ -5983,6 +5776,7 @@
           <a:lstStyle/>
           <a:p>
             <a:pPr algn="ctr"/>
+            <a:endParaRPr/>
           </a:p>
         </p:txBody>
       </p:sp>
@@ -5995,7 +5789,7 @@
           <p:nvPr/>
         </p:nvPicPr>
         <p:blipFill>
-          <a:blip r:embed="rId2"/>
+          <a:blip r:embed="rId3"/>
           <a:srcRect t="20500" b="61500"/>
           <a:stretch>
             <a:fillRect/>
@@ -6028,7 +5822,7 @@
           <a:noFill/>
         </p:spPr>
         <p:txBody>
-          <a:bodyPr wrap="square" lIns="0" rIns="0" tIns="0" bIns="0" anchor="t">
+          <a:bodyPr wrap="square" lIns="0" tIns="0" rIns="0" bIns="0" anchor="t">
             <a:spAutoFit/>
           </a:bodyPr>
           <a:lstStyle/>
@@ -6066,7 +5860,7 @@
 </file>
 
 <file path=ppt/slides/slide3.xml><?xml version="1.0" encoding="utf-8"?>
-<p:sld xmlns:a="http://schemas.openxmlformats.org/drawingml/2006/main" xmlns:p="http://schemas.openxmlformats.org/presentationml/2006/main" xmlns:r="http://schemas.openxmlformats.org/officeDocument/2006/relationships">
+<p:sld xmlns:a="http://schemas.openxmlformats.org/drawingml/2006/main" xmlns:r="http://schemas.openxmlformats.org/officeDocument/2006/relationships" xmlns:p="http://schemas.openxmlformats.org/presentationml/2006/main">
   <p:cSld>
     <p:spTree>
       <p:nvGrpSpPr>
@@ -6074,7 +5868,14 @@
         <p:cNvGrpSpPr/>
         <p:nvPr/>
       </p:nvGrpSpPr>
-      <p:grpSpPr/>
+      <p:grpSpPr>
+        <a:xfrm>
+          <a:off x="0" y="0"/>
+          <a:ext cx="0" cy="0"/>
+          <a:chOff x="0" y="0"/>
+          <a:chExt cx="0" cy="0"/>
+        </a:xfrm>
+      </p:grpSpPr>
       <p:sp>
         <p:nvSpPr>
           <p:cNvPr id="2" name="TextBox 1"/>
@@ -6092,7 +5893,7 @@
           <a:noFill/>
         </p:spPr>
         <p:txBody>
-          <a:bodyPr wrap="square" lIns="0" rIns="0" tIns="0" bIns="0" anchor="t">
+          <a:bodyPr wrap="square" lIns="0" tIns="0" rIns="0" bIns="0" anchor="t">
             <a:spAutoFit/>
           </a:bodyPr>
           <a:lstStyle/>
@@ -6138,7 +5939,7 @@
           <a:noFill/>
         </p:spPr>
         <p:txBody>
-          <a:bodyPr wrap="square" lIns="0" rIns="0" tIns="0" bIns="0" anchor="ctr">
+          <a:bodyPr wrap="square" lIns="0" tIns="0" rIns="0" bIns="0" anchor="ctr">
             <a:spAutoFit/>
           </a:bodyPr>
           <a:lstStyle/>
@@ -6254,7 +6055,7 @@
           <a:noFill/>
         </p:spPr>
         <p:txBody>
-          <a:bodyPr wrap="square" lIns="0" rIns="0" tIns="0" bIns="0" anchor="t">
+          <a:bodyPr wrap="square" lIns="0" tIns="0" rIns="0" bIns="0" anchor="t">
             <a:spAutoFit/>
           </a:bodyPr>
           <a:lstStyle/>
@@ -6300,7 +6101,7 @@
           <a:noFill/>
         </p:spPr>
         <p:txBody>
-          <a:bodyPr wrap="square" lIns="0" rIns="0" tIns="0" bIns="0" anchor="t">
+          <a:bodyPr wrap="square" lIns="0" tIns="0" rIns="0" bIns="0" anchor="t">
             <a:spAutoFit/>
           </a:bodyPr>
           <a:lstStyle/>
@@ -6346,7 +6147,7 @@
           <a:noFill/>
         </p:spPr>
         <p:txBody>
-          <a:bodyPr wrap="square" lIns="0" rIns="0" tIns="0" bIns="0" anchor="t">
+          <a:bodyPr wrap="square" lIns="0" tIns="0" rIns="0" bIns="0" anchor="t">
             <a:spAutoFit/>
           </a:bodyPr>
           <a:lstStyle/>
@@ -6419,6 +6220,7 @@
           <a:lstStyle/>
           <a:p>
             <a:pPr algn="ctr"/>
+            <a:endParaRPr/>
           </a:p>
         </p:txBody>
       </p:sp>
@@ -6431,7 +6233,7 @@
           <p:nvPr/>
         </p:nvPicPr>
         <p:blipFill>
-          <a:blip r:embed="rId2"/>
+          <a:blip r:embed="rId3"/>
           <a:stretch>
             <a:fillRect/>
           </a:stretch>
@@ -6490,6 +6292,7 @@
           <a:lstStyle/>
           <a:p>
             <a:pPr algn="ctr"/>
+            <a:endParaRPr/>
           </a:p>
         </p:txBody>
       </p:sp>
@@ -6510,7 +6313,7 @@
           <a:noFill/>
         </p:spPr>
         <p:txBody>
-          <a:bodyPr wrap="square" lIns="0" rIns="0" tIns="0" bIns="0" anchor="t">
+          <a:bodyPr wrap="square" lIns="0" tIns="0" rIns="0" bIns="0" anchor="t">
             <a:spAutoFit/>
           </a:bodyPr>
           <a:lstStyle/>
@@ -6556,7 +6359,7 @@
           <a:noFill/>
         </p:spPr>
         <p:txBody>
-          <a:bodyPr wrap="square" lIns="0" rIns="0" tIns="0" bIns="0" anchor="t">
+          <a:bodyPr wrap="square" lIns="0" tIns="0" rIns="0" bIns="0" anchor="t">
             <a:spAutoFit/>
           </a:bodyPr>
           <a:lstStyle/>
@@ -6602,7 +6405,7 @@
           <a:noFill/>
         </p:spPr>
         <p:txBody>
-          <a:bodyPr wrap="square" lIns="0" rIns="0" tIns="0" bIns="0" anchor="t">
+          <a:bodyPr wrap="square" lIns="0" tIns="0" rIns="0" bIns="0" anchor="t">
             <a:spAutoFit/>
           </a:bodyPr>
           <a:lstStyle/>
@@ -6675,6 +6478,7 @@
           <a:lstStyle/>
           <a:p>
             <a:pPr algn="ctr"/>
+            <a:endParaRPr/>
           </a:p>
         </p:txBody>
       </p:sp>
@@ -6695,7 +6499,7 @@
           <a:noFill/>
         </p:spPr>
         <p:txBody>
-          <a:bodyPr wrap="square" lIns="0" rIns="0" tIns="0" bIns="0" anchor="t">
+          <a:bodyPr wrap="square" lIns="0" tIns="0" rIns="0" bIns="0" anchor="t">
             <a:spAutoFit/>
           </a:bodyPr>
           <a:lstStyle/>
@@ -6741,7 +6545,7 @@
           <a:noFill/>
         </p:spPr>
         <p:txBody>
-          <a:bodyPr wrap="square" lIns="0" rIns="0" tIns="0" bIns="0" anchor="t">
+          <a:bodyPr wrap="square" lIns="0" tIns="0" rIns="0" bIns="0" anchor="t">
             <a:spAutoFit/>
           </a:bodyPr>
           <a:lstStyle/>
@@ -6787,7 +6591,7 @@
           <a:noFill/>
         </p:spPr>
         <p:txBody>
-          <a:bodyPr wrap="square" lIns="0" rIns="0" tIns="0" bIns="0" anchor="t">
+          <a:bodyPr wrap="square" lIns="0" tIns="0" rIns="0" bIns="0" anchor="t">
             <a:spAutoFit/>
           </a:bodyPr>
           <a:lstStyle/>
@@ -6860,6 +6664,7 @@
           <a:lstStyle/>
           <a:p>
             <a:pPr algn="ctr"/>
+            <a:endParaRPr/>
           </a:p>
         </p:txBody>
       </p:sp>
@@ -6880,7 +6685,7 @@
           <a:noFill/>
         </p:spPr>
         <p:txBody>
-          <a:bodyPr wrap="square" lIns="0" rIns="0" tIns="0" bIns="0" anchor="t">
+          <a:bodyPr wrap="square" lIns="0" tIns="0" rIns="0" bIns="0" anchor="t">
             <a:spAutoFit/>
           </a:bodyPr>
           <a:lstStyle/>
@@ -6926,7 +6731,7 @@
           <a:noFill/>
         </p:spPr>
         <p:txBody>
-          <a:bodyPr wrap="square" lIns="0" rIns="0" tIns="0" bIns="0" anchor="t">
+          <a:bodyPr wrap="square" lIns="0" tIns="0" rIns="0" bIns="0" anchor="t">
             <a:spAutoFit/>
           </a:bodyPr>
           <a:lstStyle/>
@@ -6972,7 +6777,7 @@
           <a:noFill/>
         </p:spPr>
         <p:txBody>
-          <a:bodyPr wrap="square" lIns="0" rIns="0" tIns="0" bIns="0" anchor="t">
+          <a:bodyPr wrap="square" lIns="0" tIns="0" rIns="0" bIns="0" anchor="t">
             <a:spAutoFit/>
           </a:bodyPr>
           <a:lstStyle/>
@@ -7010,7 +6815,7 @@
 </file>
 
 <file path=ppt/slides/slide4.xml><?xml version="1.0" encoding="utf-8"?>
-<p:sld xmlns:a="http://schemas.openxmlformats.org/drawingml/2006/main" xmlns:p="http://schemas.openxmlformats.org/presentationml/2006/main" xmlns:r="http://schemas.openxmlformats.org/officeDocument/2006/relationships">
+<p:sld xmlns:a="http://schemas.openxmlformats.org/drawingml/2006/main" xmlns:r="http://schemas.openxmlformats.org/officeDocument/2006/relationships" xmlns:p="http://schemas.openxmlformats.org/presentationml/2006/main">
   <p:cSld>
     <p:spTree>
       <p:nvGrpSpPr>
@@ -7018,7 +6823,14 @@
         <p:cNvGrpSpPr/>
         <p:nvPr/>
       </p:nvGrpSpPr>
-      <p:grpSpPr/>
+      <p:grpSpPr>
+        <a:xfrm>
+          <a:off x="0" y="0"/>
+          <a:ext cx="0" cy="0"/>
+          <a:chOff x="0" y="0"/>
+          <a:chExt cx="0" cy="0"/>
+        </a:xfrm>
+      </p:grpSpPr>
       <p:sp>
         <p:nvSpPr>
           <p:cNvPr id="2" name="TextBox 1"/>
@@ -7036,7 +6848,7 @@
           <a:noFill/>
         </p:spPr>
         <p:txBody>
-          <a:bodyPr wrap="square" lIns="0" rIns="0" tIns="0" bIns="0" anchor="t">
+          <a:bodyPr wrap="square" lIns="0" tIns="0" rIns="0" bIns="0" anchor="t">
             <a:spAutoFit/>
           </a:bodyPr>
           <a:lstStyle/>
@@ -7082,7 +6894,7 @@
           <a:noFill/>
         </p:spPr>
         <p:txBody>
-          <a:bodyPr wrap="square" lIns="0" rIns="0" tIns="0" bIns="0" anchor="ctr">
+          <a:bodyPr wrap="square" lIns="0" tIns="0" rIns="0" bIns="0" anchor="ctr">
             <a:spAutoFit/>
           </a:bodyPr>
           <a:lstStyle/>
@@ -7198,7 +7010,7 @@
           <a:noFill/>
         </p:spPr>
         <p:txBody>
-          <a:bodyPr wrap="square" lIns="0" rIns="0" tIns="0" bIns="0" anchor="t">
+          <a:bodyPr wrap="square" lIns="0" tIns="0" rIns="0" bIns="0" anchor="t">
             <a:spAutoFit/>
           </a:bodyPr>
           <a:lstStyle/>
@@ -7244,7 +7056,7 @@
           <a:noFill/>
         </p:spPr>
         <p:txBody>
-          <a:bodyPr wrap="square" lIns="0" rIns="0" tIns="0" bIns="0" anchor="t">
+          <a:bodyPr wrap="square" lIns="0" tIns="0" rIns="0" bIns="0" anchor="t">
             <a:spAutoFit/>
           </a:bodyPr>
           <a:lstStyle/>
@@ -7290,7 +7102,7 @@
           <a:noFill/>
         </p:spPr>
         <p:txBody>
-          <a:bodyPr wrap="square" lIns="0" rIns="0" tIns="0" bIns="0" anchor="t">
+          <a:bodyPr wrap="square" lIns="0" tIns="0" rIns="0" bIns="0" anchor="t">
             <a:spAutoFit/>
           </a:bodyPr>
           <a:lstStyle/>
@@ -7363,6 +7175,7 @@
           <a:lstStyle/>
           <a:p>
             <a:pPr algn="ctr"/>
+            <a:endParaRPr/>
           </a:p>
         </p:txBody>
       </p:sp>
@@ -7383,7 +7196,7 @@
           <a:noFill/>
         </p:spPr>
         <p:txBody>
-          <a:bodyPr wrap="square" lIns="0" rIns="0" tIns="0" bIns="0" anchor="ctr">
+          <a:bodyPr wrap="square" lIns="0" tIns="0" rIns="0" bIns="0" anchor="ctr">
             <a:spAutoFit/>
           </a:bodyPr>
           <a:lstStyle/>
@@ -7429,7 +7242,7 @@
           <a:noFill/>
         </p:spPr>
         <p:txBody>
-          <a:bodyPr wrap="square" lIns="0" rIns="0" tIns="0" bIns="0" anchor="t">
+          <a:bodyPr wrap="square" lIns="0" tIns="0" rIns="0" bIns="0" anchor="t">
             <a:spAutoFit/>
           </a:bodyPr>
           <a:lstStyle/>
@@ -7502,6 +7315,7 @@
           <a:lstStyle/>
           <a:p>
             <a:pPr algn="ctr"/>
+            <a:endParaRPr/>
           </a:p>
         </p:txBody>
       </p:sp>
@@ -7522,7 +7336,7 @@
           <a:noFill/>
         </p:spPr>
         <p:txBody>
-          <a:bodyPr wrap="square" lIns="0" rIns="0" tIns="0" bIns="0" anchor="ctr">
+          <a:bodyPr wrap="square" lIns="0" tIns="0" rIns="0" bIns="0" anchor="ctr">
             <a:spAutoFit/>
           </a:bodyPr>
           <a:lstStyle/>
@@ -7568,7 +7382,7 @@
           <a:noFill/>
         </p:spPr>
         <p:txBody>
-          <a:bodyPr wrap="square" lIns="0" rIns="0" tIns="0" bIns="0" anchor="t">
+          <a:bodyPr wrap="square" lIns="0" tIns="0" rIns="0" bIns="0" anchor="t">
             <a:spAutoFit/>
           </a:bodyPr>
           <a:lstStyle/>
@@ -7641,6 +7455,7 @@
           <a:lstStyle/>
           <a:p>
             <a:pPr algn="ctr"/>
+            <a:endParaRPr/>
           </a:p>
         </p:txBody>
       </p:sp>
@@ -7661,7 +7476,7 @@
           <a:noFill/>
         </p:spPr>
         <p:txBody>
-          <a:bodyPr wrap="square" lIns="0" rIns="0" tIns="0" bIns="0" anchor="ctr">
+          <a:bodyPr wrap="square" lIns="0" tIns="0" rIns="0" bIns="0" anchor="ctr">
             <a:spAutoFit/>
           </a:bodyPr>
           <a:lstStyle/>
@@ -7707,7 +7522,7 @@
           <a:noFill/>
         </p:spPr>
         <p:txBody>
-          <a:bodyPr wrap="square" lIns="0" rIns="0" tIns="0" bIns="0" anchor="t">
+          <a:bodyPr wrap="square" lIns="0" tIns="0" rIns="0" bIns="0" anchor="t">
             <a:spAutoFit/>
           </a:bodyPr>
           <a:lstStyle/>
@@ -7753,7 +7568,7 @@
           <a:noFill/>
         </p:spPr>
         <p:txBody>
-          <a:bodyPr wrap="square" lIns="0" rIns="0" tIns="0" bIns="0" anchor="t">
+          <a:bodyPr wrap="square" lIns="0" tIns="0" rIns="0" bIns="0" anchor="t">
             <a:spAutoFit/>
           </a:bodyPr>
           <a:lstStyle/>
@@ -7826,6 +7641,7 @@
           <a:lstStyle/>
           <a:p>
             <a:pPr algn="ctr"/>
+            <a:endParaRPr/>
           </a:p>
         </p:txBody>
       </p:sp>
@@ -7846,7 +7662,7 @@
           <a:noFill/>
         </p:spPr>
         <p:txBody>
-          <a:bodyPr wrap="square" lIns="0" rIns="0" tIns="0" bIns="0" anchor="t">
+          <a:bodyPr wrap="square" lIns="0" tIns="0" rIns="0" bIns="0" anchor="t">
             <a:spAutoFit/>
           </a:bodyPr>
           <a:lstStyle/>
@@ -7892,7 +7708,7 @@
           <a:noFill/>
         </p:spPr>
         <p:txBody>
-          <a:bodyPr wrap="square" lIns="0" rIns="0" tIns="0" bIns="0" anchor="ctr">
+          <a:bodyPr wrap="square" lIns="0" tIns="0" rIns="0" bIns="0" anchor="ctr">
             <a:spAutoFit/>
           </a:bodyPr>
           <a:lstStyle/>
@@ -7965,6 +7781,7 @@
           <a:lstStyle/>
           <a:p>
             <a:pPr algn="ctr"/>
+            <a:endParaRPr/>
           </a:p>
         </p:txBody>
       </p:sp>
@@ -7985,7 +7802,7 @@
           <a:noFill/>
         </p:spPr>
         <p:txBody>
-          <a:bodyPr wrap="square" lIns="0" rIns="0" tIns="0" bIns="0" anchor="t">
+          <a:bodyPr wrap="square" lIns="0" tIns="0" rIns="0" bIns="0" anchor="t">
             <a:spAutoFit/>
           </a:bodyPr>
           <a:lstStyle/>
@@ -8031,7 +7848,7 @@
           <a:noFill/>
         </p:spPr>
         <p:txBody>
-          <a:bodyPr wrap="square" lIns="0" rIns="0" tIns="0" bIns="0" anchor="ctr">
+          <a:bodyPr wrap="square" lIns="0" tIns="0" rIns="0" bIns="0" anchor="ctr">
             <a:spAutoFit/>
           </a:bodyPr>
           <a:lstStyle/>
@@ -8104,6 +7921,7 @@
           <a:lstStyle/>
           <a:p>
             <a:pPr algn="ctr"/>
+            <a:endParaRPr/>
           </a:p>
         </p:txBody>
       </p:sp>
@@ -8124,7 +7942,7 @@
           <a:noFill/>
         </p:spPr>
         <p:txBody>
-          <a:bodyPr wrap="square" lIns="0" rIns="0" tIns="0" bIns="0" anchor="t">
+          <a:bodyPr wrap="square" lIns="0" tIns="0" rIns="0" bIns="0" anchor="t">
             <a:spAutoFit/>
           </a:bodyPr>
           <a:lstStyle/>
@@ -8170,7 +7988,7 @@
           <a:noFill/>
         </p:spPr>
         <p:txBody>
-          <a:bodyPr wrap="square" lIns="0" rIns="0" tIns="0" bIns="0" anchor="ctr">
+          <a:bodyPr wrap="square" lIns="0" tIns="0" rIns="0" bIns="0" anchor="ctr">
             <a:spAutoFit/>
           </a:bodyPr>
           <a:lstStyle/>
@@ -8243,6 +8061,7 @@
           <a:lstStyle/>
           <a:p>
             <a:pPr algn="ctr"/>
+            <a:endParaRPr/>
           </a:p>
         </p:txBody>
       </p:sp>
@@ -8263,7 +8082,7 @@
           <a:noFill/>
         </p:spPr>
         <p:txBody>
-          <a:bodyPr wrap="square" lIns="0" rIns="0" tIns="0" bIns="0" anchor="t">
+          <a:bodyPr wrap="square" lIns="0" tIns="0" rIns="0" bIns="0" anchor="t">
             <a:spAutoFit/>
           </a:bodyPr>
           <a:lstStyle/>
@@ -8309,7 +8128,7 @@
           <a:noFill/>
         </p:spPr>
         <p:txBody>
-          <a:bodyPr wrap="square" lIns="0" rIns="0" tIns="0" bIns="0" anchor="ctr">
+          <a:bodyPr wrap="square" lIns="0" tIns="0" rIns="0" bIns="0" anchor="ctr">
             <a:spAutoFit/>
           </a:bodyPr>
           <a:lstStyle/>
@@ -8382,6 +8201,7 @@
           <a:lstStyle/>
           <a:p>
             <a:pPr algn="ctr"/>
+            <a:endParaRPr/>
           </a:p>
         </p:txBody>
       </p:sp>
@@ -8402,7 +8222,7 @@
           <a:noFill/>
         </p:spPr>
         <p:txBody>
-          <a:bodyPr wrap="square" lIns="0" rIns="0" tIns="0" bIns="0" anchor="t">
+          <a:bodyPr wrap="square" lIns="0" tIns="0" rIns="0" bIns="0" anchor="t">
             <a:spAutoFit/>
           </a:bodyPr>
           <a:lstStyle/>
@@ -8448,7 +8268,7 @@
           <a:noFill/>
         </p:spPr>
         <p:txBody>
-          <a:bodyPr wrap="square" lIns="0" rIns="0" tIns="0" bIns="0" anchor="ctr">
+          <a:bodyPr wrap="square" lIns="0" tIns="0" rIns="0" bIns="0" anchor="ctr">
             <a:spAutoFit/>
           </a:bodyPr>
           <a:lstStyle/>
@@ -8521,6 +8341,7 @@
           <a:lstStyle/>
           <a:p>
             <a:pPr algn="ctr"/>
+            <a:endParaRPr/>
           </a:p>
         </p:txBody>
       </p:sp>
@@ -8541,7 +8362,7 @@
           <a:noFill/>
         </p:spPr>
         <p:txBody>
-          <a:bodyPr wrap="square" lIns="0" rIns="0" tIns="0" bIns="0" anchor="t">
+          <a:bodyPr wrap="square" lIns="0" tIns="0" rIns="0" bIns="0" anchor="t">
             <a:spAutoFit/>
           </a:bodyPr>
           <a:lstStyle/>
@@ -8594,7 +8415,7 @@
           <a:noFill/>
         </p:spPr>
         <p:txBody>
-          <a:bodyPr wrap="square" lIns="0" rIns="0" tIns="0" bIns="0" anchor="t">
+          <a:bodyPr wrap="square" lIns="0" tIns="0" rIns="0" bIns="0" anchor="t">
             <a:spAutoFit/>
           </a:bodyPr>
           <a:lstStyle/>
@@ -8667,6 +8488,7 @@
           <a:lstStyle/>
           <a:p>
             <a:pPr algn="ctr"/>
+            <a:endParaRPr/>
           </a:p>
         </p:txBody>
       </p:sp>
@@ -8679,7 +8501,7 @@
           <p:nvPr/>
         </p:nvPicPr>
         <p:blipFill>
-          <a:blip r:embed="rId2"/>
+          <a:blip r:embed="rId3"/>
           <a:stretch>
             <a:fillRect/>
           </a:stretch>
@@ -8711,7 +8533,7 @@
           <a:noFill/>
         </p:spPr>
         <p:txBody>
-          <a:bodyPr wrap="square" lIns="0" rIns="0" tIns="0" bIns="0" anchor="t">
+          <a:bodyPr wrap="square" lIns="0" tIns="0" rIns="0" bIns="0" anchor="t">
             <a:spAutoFit/>
           </a:bodyPr>
           <a:lstStyle/>
@@ -8749,7 +8571,7 @@
 </file>
 
 <file path=ppt/slides/slide5.xml><?xml version="1.0" encoding="utf-8"?>
-<p:sld xmlns:a="http://schemas.openxmlformats.org/drawingml/2006/main" xmlns:p="http://schemas.openxmlformats.org/presentationml/2006/main" xmlns:r="http://schemas.openxmlformats.org/officeDocument/2006/relationships">
+<p:sld xmlns:a="http://schemas.openxmlformats.org/drawingml/2006/main" xmlns:r="http://schemas.openxmlformats.org/officeDocument/2006/relationships" xmlns:p="http://schemas.openxmlformats.org/presentationml/2006/main">
   <p:cSld>
     <p:spTree>
       <p:nvGrpSpPr>
@@ -8757,7 +8579,14 @@
         <p:cNvGrpSpPr/>
         <p:nvPr/>
       </p:nvGrpSpPr>
-      <p:grpSpPr/>
+      <p:grpSpPr>
+        <a:xfrm>
+          <a:off x="0" y="0"/>
+          <a:ext cx="0" cy="0"/>
+          <a:chOff x="0" y="0"/>
+          <a:chExt cx="0" cy="0"/>
+        </a:xfrm>
+      </p:grpSpPr>
       <p:sp>
         <p:nvSpPr>
           <p:cNvPr id="2" name="TextBox 1"/>
@@ -8775,7 +8604,7 @@
           <a:noFill/>
         </p:spPr>
         <p:txBody>
-          <a:bodyPr wrap="square" lIns="0" rIns="0" tIns="0" bIns="0" anchor="t">
+          <a:bodyPr wrap="square" lIns="0" tIns="0" rIns="0" bIns="0" anchor="t">
             <a:spAutoFit/>
           </a:bodyPr>
           <a:lstStyle/>
@@ -8821,7 +8650,7 @@
           <a:noFill/>
         </p:spPr>
         <p:txBody>
-          <a:bodyPr wrap="square" lIns="0" rIns="0" tIns="0" bIns="0" anchor="ctr">
+          <a:bodyPr wrap="square" lIns="0" tIns="0" rIns="0" bIns="0" anchor="ctr">
             <a:spAutoFit/>
           </a:bodyPr>
           <a:lstStyle/>
@@ -8937,7 +8766,7 @@
           <a:noFill/>
         </p:spPr>
         <p:txBody>
-          <a:bodyPr wrap="square" lIns="0" rIns="0" tIns="0" bIns="0" anchor="t">
+          <a:bodyPr wrap="square" lIns="0" tIns="0" rIns="0" bIns="0" anchor="t">
             <a:spAutoFit/>
           </a:bodyPr>
           <a:lstStyle/>
@@ -8983,7 +8812,7 @@
           <a:noFill/>
         </p:spPr>
         <p:txBody>
-          <a:bodyPr wrap="square" lIns="0" rIns="0" tIns="0" bIns="0" anchor="t">
+          <a:bodyPr wrap="square" lIns="0" tIns="0" rIns="0" bIns="0" anchor="t">
             <a:spAutoFit/>
           </a:bodyPr>
           <a:lstStyle/>
@@ -9029,7 +8858,7 @@
           <a:noFill/>
         </p:spPr>
         <p:txBody>
-          <a:bodyPr wrap="square" lIns="0" rIns="0" tIns="0" bIns="0" anchor="t">
+          <a:bodyPr wrap="square" lIns="0" tIns="0" rIns="0" bIns="0" anchor="t">
             <a:spAutoFit/>
           </a:bodyPr>
           <a:lstStyle/>
@@ -9102,6 +8931,7 @@
           <a:lstStyle/>
           <a:p>
             <a:pPr algn="ctr"/>
+            <a:endParaRPr/>
           </a:p>
         </p:txBody>
       </p:sp>
@@ -9114,7 +8944,7 @@
           <p:nvPr/>
         </p:nvPicPr>
         <p:blipFill>
-          <a:blip r:embed="rId2"/>
+          <a:blip r:embed="rId3"/>
           <a:stretch>
             <a:fillRect/>
           </a:stretch>
@@ -9173,6 +9003,7 @@
           <a:lstStyle/>
           <a:p>
             <a:pPr algn="ctr"/>
+            <a:endParaRPr/>
           </a:p>
         </p:txBody>
       </p:sp>
@@ -9193,7 +9024,7 @@
           <a:noFill/>
         </p:spPr>
         <p:txBody>
-          <a:bodyPr wrap="square" lIns="0" rIns="0" tIns="0" bIns="0" anchor="t">
+          <a:bodyPr wrap="square" lIns="0" tIns="0" rIns="0" bIns="0" anchor="t">
             <a:spAutoFit/>
           </a:bodyPr>
           <a:lstStyle/>
@@ -9239,7 +9070,7 @@
           <a:noFill/>
         </p:spPr>
         <p:txBody>
-          <a:bodyPr wrap="square" lIns="0" rIns="0" tIns="0" bIns="0" anchor="t">
+          <a:bodyPr wrap="square" lIns="0" tIns="0" rIns="0" bIns="0" anchor="t">
             <a:spAutoFit/>
           </a:bodyPr>
           <a:lstStyle/>
@@ -9312,6 +9143,7 @@
           <a:lstStyle/>
           <a:p>
             <a:pPr algn="ctr"/>
+            <a:endParaRPr/>
           </a:p>
         </p:txBody>
       </p:sp>
@@ -9332,7 +9164,7 @@
           <a:noFill/>
         </p:spPr>
         <p:txBody>
-          <a:bodyPr wrap="square" lIns="0" rIns="0" tIns="0" bIns="0" anchor="t">
+          <a:bodyPr wrap="square" lIns="0" tIns="0" rIns="0" bIns="0" anchor="t">
             <a:spAutoFit/>
           </a:bodyPr>
           <a:lstStyle/>
@@ -9378,7 +9210,7 @@
           <a:noFill/>
         </p:spPr>
         <p:txBody>
-          <a:bodyPr wrap="square" lIns="0" rIns="0" tIns="0" bIns="0" anchor="t">
+          <a:bodyPr wrap="square" lIns="0" tIns="0" rIns="0" bIns="0" anchor="t">
             <a:spAutoFit/>
           </a:bodyPr>
           <a:lstStyle/>
@@ -9424,7 +9256,7 @@
           <a:noFill/>
         </p:spPr>
         <p:txBody>
-          <a:bodyPr wrap="square" lIns="0" rIns="0" tIns="0" bIns="0" anchor="t">
+          <a:bodyPr wrap="square" lIns="0" tIns="0" rIns="0" bIns="0" anchor="t">
             <a:spAutoFit/>
           </a:bodyPr>
           <a:lstStyle/>
@@ -9497,6 +9329,7 @@
           <a:lstStyle/>
           <a:p>
             <a:pPr algn="ctr"/>
+            <a:endParaRPr/>
           </a:p>
         </p:txBody>
       </p:sp>
@@ -9517,7 +9350,7 @@
           <a:noFill/>
         </p:spPr>
         <p:txBody>
-          <a:bodyPr wrap="square" lIns="0" rIns="0" tIns="0" bIns="0" anchor="t">
+          <a:bodyPr wrap="square" lIns="0" tIns="0" rIns="0" bIns="0" anchor="t">
             <a:spAutoFit/>
           </a:bodyPr>
           <a:lstStyle/>
@@ -9563,7 +9396,7 @@
           <a:noFill/>
         </p:spPr>
         <p:txBody>
-          <a:bodyPr wrap="square" lIns="0" rIns="0" tIns="0" bIns="0" anchor="t">
+          <a:bodyPr wrap="square" lIns="0" tIns="0" rIns="0" bIns="0" anchor="t">
             <a:spAutoFit/>
           </a:bodyPr>
           <a:lstStyle/>
@@ -9609,7 +9442,7 @@
           <a:noFill/>
         </p:spPr>
         <p:txBody>
-          <a:bodyPr wrap="square" lIns="0" rIns="0" tIns="0" bIns="0" anchor="t">
+          <a:bodyPr wrap="square" lIns="0" tIns="0" rIns="0" bIns="0" anchor="t">
             <a:spAutoFit/>
           </a:bodyPr>
           <a:lstStyle/>
@@ -9682,6 +9515,7 @@
           <a:lstStyle/>
           <a:p>
             <a:pPr algn="ctr"/>
+            <a:endParaRPr/>
           </a:p>
         </p:txBody>
       </p:sp>
@@ -9702,7 +9536,7 @@
           <a:noFill/>
         </p:spPr>
         <p:txBody>
-          <a:bodyPr wrap="square" lIns="0" rIns="0" tIns="0" bIns="0" anchor="t">
+          <a:bodyPr wrap="square" lIns="0" tIns="0" rIns="0" bIns="0" anchor="t">
             <a:spAutoFit/>
           </a:bodyPr>
           <a:lstStyle/>
@@ -9783,7 +9617,7 @@
           <a:noFill/>
         </p:spPr>
         <p:txBody>
-          <a:bodyPr wrap="square" lIns="0" rIns="0" tIns="0" bIns="0" anchor="t">
+          <a:bodyPr wrap="square" lIns="0" tIns="0" rIns="0" bIns="0" anchor="t">
             <a:spAutoFit/>
           </a:bodyPr>
           <a:lstStyle/>
@@ -9829,7 +9663,7 @@
           <a:noFill/>
         </p:spPr>
         <p:txBody>
-          <a:bodyPr wrap="square" lIns="0" rIns="0" tIns="0" bIns="0" anchor="t">
+          <a:bodyPr wrap="square" lIns="0" tIns="0" rIns="0" bIns="0" anchor="t">
             <a:spAutoFit/>
           </a:bodyPr>
           <a:lstStyle/>
@@ -9867,7 +9701,7 @@
 </file>
 
 <file path=ppt/slides/slide6.xml><?xml version="1.0" encoding="utf-8"?>
-<p:sld xmlns:a="http://schemas.openxmlformats.org/drawingml/2006/main" xmlns:p="http://schemas.openxmlformats.org/presentationml/2006/main" xmlns:r="http://schemas.openxmlformats.org/officeDocument/2006/relationships">
+<p:sld xmlns:a="http://schemas.openxmlformats.org/drawingml/2006/main" xmlns:r="http://schemas.openxmlformats.org/officeDocument/2006/relationships" xmlns:p="http://schemas.openxmlformats.org/presentationml/2006/main">
   <p:cSld>
     <p:spTree>
       <p:nvGrpSpPr>
@@ -9875,7 +9709,14 @@
         <p:cNvGrpSpPr/>
         <p:nvPr/>
       </p:nvGrpSpPr>
-      <p:grpSpPr/>
+      <p:grpSpPr>
+        <a:xfrm>
+          <a:off x="0" y="0"/>
+          <a:ext cx="0" cy="0"/>
+          <a:chOff x="0" y="0"/>
+          <a:chExt cx="0" cy="0"/>
+        </a:xfrm>
+      </p:grpSpPr>
       <p:sp>
         <p:nvSpPr>
           <p:cNvPr id="2" name="TextBox 1"/>
@@ -9893,7 +9734,7 @@
           <a:noFill/>
         </p:spPr>
         <p:txBody>
-          <a:bodyPr wrap="square" lIns="0" rIns="0" tIns="0" bIns="0" anchor="t">
+          <a:bodyPr wrap="square" lIns="0" tIns="0" rIns="0" bIns="0" anchor="t">
             <a:spAutoFit/>
           </a:bodyPr>
           <a:lstStyle/>
@@ -9939,7 +9780,7 @@
           <a:noFill/>
         </p:spPr>
         <p:txBody>
-          <a:bodyPr wrap="square" lIns="0" rIns="0" tIns="0" bIns="0" anchor="ctr">
+          <a:bodyPr wrap="square" lIns="0" tIns="0" rIns="0" bIns="0" anchor="ctr">
             <a:spAutoFit/>
           </a:bodyPr>
           <a:lstStyle/>
@@ -10055,7 +9896,7 @@
           <a:noFill/>
         </p:spPr>
         <p:txBody>
-          <a:bodyPr wrap="square" lIns="0" rIns="0" tIns="0" bIns="0" anchor="t">
+          <a:bodyPr wrap="square" lIns="0" tIns="0" rIns="0" bIns="0" anchor="t">
             <a:spAutoFit/>
           </a:bodyPr>
           <a:lstStyle/>
@@ -10101,7 +9942,7 @@
           <a:noFill/>
         </p:spPr>
         <p:txBody>
-          <a:bodyPr wrap="square" lIns="0" rIns="0" tIns="0" bIns="0" anchor="t">
+          <a:bodyPr wrap="square" lIns="0" tIns="0" rIns="0" bIns="0" anchor="t">
             <a:spAutoFit/>
           </a:bodyPr>
           <a:lstStyle/>
@@ -10147,7 +9988,7 @@
           <a:noFill/>
         </p:spPr>
         <p:txBody>
-          <a:bodyPr wrap="square" lIns="0" rIns="0" tIns="0" bIns="0" anchor="t">
+          <a:bodyPr wrap="square" lIns="0" tIns="0" rIns="0" bIns="0" anchor="t">
             <a:spAutoFit/>
           </a:bodyPr>
           <a:lstStyle/>
@@ -10220,6 +10061,7 @@
           <a:lstStyle/>
           <a:p>
             <a:pPr algn="ctr"/>
+            <a:endParaRPr/>
           </a:p>
         </p:txBody>
       </p:sp>
@@ -10232,7 +10074,7 @@
           <p:nvPr/>
         </p:nvPicPr>
         <p:blipFill>
-          <a:blip r:embed="rId2"/>
+          <a:blip r:embed="rId3"/>
           <a:stretch>
             <a:fillRect/>
           </a:stretch>
@@ -10291,6 +10133,7 @@
           <a:lstStyle/>
           <a:p>
             <a:pPr algn="ctr"/>
+            <a:endParaRPr/>
           </a:p>
         </p:txBody>
       </p:sp>
@@ -10311,7 +10154,7 @@
           <a:noFill/>
         </p:spPr>
         <p:txBody>
-          <a:bodyPr wrap="square" lIns="0" rIns="0" tIns="0" bIns="0" anchor="t">
+          <a:bodyPr wrap="square" lIns="0" tIns="0" rIns="0" bIns="0" anchor="t">
             <a:spAutoFit/>
           </a:bodyPr>
           <a:lstStyle/>
@@ -10357,7 +10200,7 @@
           <a:noFill/>
         </p:spPr>
         <p:txBody>
-          <a:bodyPr wrap="square" lIns="0" rIns="0" tIns="0" bIns="0" anchor="t">
+          <a:bodyPr wrap="square" lIns="0" tIns="0" rIns="0" bIns="0" anchor="t">
             <a:spAutoFit/>
           </a:bodyPr>
           <a:lstStyle/>
@@ -10403,7 +10246,7 @@
           <a:noFill/>
         </p:spPr>
         <p:txBody>
-          <a:bodyPr wrap="square" lIns="0" rIns="0" tIns="0" bIns="0" anchor="t">
+          <a:bodyPr wrap="square" lIns="0" tIns="0" rIns="0" bIns="0" anchor="t">
             <a:spAutoFit/>
           </a:bodyPr>
           <a:lstStyle/>
@@ -10476,6 +10319,7 @@
           <a:lstStyle/>
           <a:p>
             <a:pPr algn="ctr"/>
+            <a:endParaRPr/>
           </a:p>
         </p:txBody>
       </p:sp>
@@ -10496,7 +10340,7 @@
           <a:noFill/>
         </p:spPr>
         <p:txBody>
-          <a:bodyPr wrap="square" lIns="0" rIns="0" tIns="0" bIns="0" anchor="t">
+          <a:bodyPr wrap="square" lIns="0" tIns="0" rIns="0" bIns="0" anchor="t">
             <a:spAutoFit/>
           </a:bodyPr>
           <a:lstStyle/>
@@ -10542,7 +10386,7 @@
           <a:noFill/>
         </p:spPr>
         <p:txBody>
-          <a:bodyPr wrap="square" lIns="0" rIns="0" tIns="0" bIns="0" anchor="t">
+          <a:bodyPr wrap="square" lIns="0" tIns="0" rIns="0" bIns="0" anchor="t">
             <a:spAutoFit/>
           </a:bodyPr>
           <a:lstStyle/>
@@ -10588,7 +10432,7 @@
           <a:noFill/>
         </p:spPr>
         <p:txBody>
-          <a:bodyPr wrap="square" lIns="0" rIns="0" tIns="0" bIns="0" anchor="t">
+          <a:bodyPr wrap="square" lIns="0" tIns="0" rIns="0" bIns="0" anchor="t">
             <a:spAutoFit/>
           </a:bodyPr>
           <a:lstStyle/>
@@ -10661,6 +10505,7 @@
           <a:lstStyle/>
           <a:p>
             <a:pPr algn="ctr"/>
+            <a:endParaRPr/>
           </a:p>
         </p:txBody>
       </p:sp>
@@ -10681,7 +10526,7 @@
           <a:noFill/>
         </p:spPr>
         <p:txBody>
-          <a:bodyPr wrap="square" lIns="0" rIns="0" tIns="0" bIns="0" anchor="t">
+          <a:bodyPr wrap="square" lIns="0" tIns="0" rIns="0" bIns="0" anchor="t">
             <a:spAutoFit/>
           </a:bodyPr>
           <a:lstStyle/>
@@ -10727,7 +10572,7 @@
           <a:noFill/>
         </p:spPr>
         <p:txBody>
-          <a:bodyPr wrap="square" lIns="0" rIns="0" tIns="0" bIns="0" anchor="t">
+          <a:bodyPr wrap="square" lIns="0" tIns="0" rIns="0" bIns="0" anchor="t">
             <a:spAutoFit/>
           </a:bodyPr>
           <a:lstStyle/>
@@ -10765,7 +10610,7 @@
 </file>
 
 <file path=ppt/slides/slide7.xml><?xml version="1.0" encoding="utf-8"?>
-<p:sld xmlns:a="http://schemas.openxmlformats.org/drawingml/2006/main" xmlns:p="http://schemas.openxmlformats.org/presentationml/2006/main" xmlns:r="http://schemas.openxmlformats.org/officeDocument/2006/relationships">
+<p:sld xmlns:a="http://schemas.openxmlformats.org/drawingml/2006/main" xmlns:r="http://schemas.openxmlformats.org/officeDocument/2006/relationships" xmlns:p="http://schemas.openxmlformats.org/presentationml/2006/main">
   <p:cSld>
     <p:spTree>
       <p:nvGrpSpPr>
@@ -10773,7 +10618,14 @@
         <p:cNvGrpSpPr/>
         <p:nvPr/>
       </p:nvGrpSpPr>
-      <p:grpSpPr/>
+      <p:grpSpPr>
+        <a:xfrm>
+          <a:off x="0" y="0"/>
+          <a:ext cx="0" cy="0"/>
+          <a:chOff x="0" y="0"/>
+          <a:chExt cx="0" cy="0"/>
+        </a:xfrm>
+      </p:grpSpPr>
       <p:sp>
         <p:nvSpPr>
           <p:cNvPr id="2" name="TextBox 1"/>
@@ -10791,7 +10643,7 @@
           <a:noFill/>
         </p:spPr>
         <p:txBody>
-          <a:bodyPr wrap="square" lIns="0" rIns="0" tIns="0" bIns="0" anchor="t">
+          <a:bodyPr wrap="square" lIns="0" tIns="0" rIns="0" bIns="0" anchor="t">
             <a:spAutoFit/>
           </a:bodyPr>
           <a:lstStyle/>
@@ -10837,7 +10689,7 @@
           <a:noFill/>
         </p:spPr>
         <p:txBody>
-          <a:bodyPr wrap="square" lIns="0" rIns="0" tIns="0" bIns="0" anchor="ctr">
+          <a:bodyPr wrap="square" lIns="0" tIns="0" rIns="0" bIns="0" anchor="ctr">
             <a:spAutoFit/>
           </a:bodyPr>
           <a:lstStyle/>
@@ -10953,7 +10805,7 @@
           <a:noFill/>
         </p:spPr>
         <p:txBody>
-          <a:bodyPr wrap="square" lIns="0" rIns="0" tIns="0" bIns="0" anchor="t">
+          <a:bodyPr wrap="square" lIns="0" tIns="0" rIns="0" bIns="0" anchor="t">
             <a:spAutoFit/>
           </a:bodyPr>
           <a:lstStyle/>
@@ -10999,7 +10851,7 @@
           <a:noFill/>
         </p:spPr>
         <p:txBody>
-          <a:bodyPr wrap="square" lIns="0" rIns="0" tIns="0" bIns="0" anchor="t">
+          <a:bodyPr wrap="square" lIns="0" tIns="0" rIns="0" bIns="0" anchor="t">
             <a:spAutoFit/>
           </a:bodyPr>
           <a:lstStyle/>
@@ -11045,7 +10897,7 @@
           <a:noFill/>
         </p:spPr>
         <p:txBody>
-          <a:bodyPr wrap="square" lIns="0" rIns="0" tIns="0" bIns="0" anchor="t">
+          <a:bodyPr wrap="square" lIns="0" tIns="0" rIns="0" bIns="0" anchor="t">
             <a:spAutoFit/>
           </a:bodyPr>
           <a:lstStyle/>
@@ -11093,15 +10945,39 @@
                 <a:tableStyleId>{5C22544A-7EE6-4342-B048-85BDC9FD1C3A}</a:tableStyleId>
               </a:tblPr>
               <a:tblGrid>
-                <a:gridCol w="2834640"/>
-                <a:gridCol w="1408176"/>
-                <a:gridCol w="1408176"/>
-                <a:gridCol w="1892807"/>
+                <a:gridCol w="2834640">
+                  <a:extLst>
+                    <a:ext uri="{9D8B030D-6E8A-4147-A177-3AD203B41FA5}">
+                      <a16:colId xmlns:a16="http://schemas.microsoft.com/office/drawing/2014/main" val="20000"/>
+                    </a:ext>
+                  </a:extLst>
+                </a:gridCol>
+                <a:gridCol w="1408176">
+                  <a:extLst>
+                    <a:ext uri="{9D8B030D-6E8A-4147-A177-3AD203B41FA5}">
+                      <a16:colId xmlns:a16="http://schemas.microsoft.com/office/drawing/2014/main" val="20001"/>
+                    </a:ext>
+                  </a:extLst>
+                </a:gridCol>
+                <a:gridCol w="1408176">
+                  <a:extLst>
+                    <a:ext uri="{9D8B030D-6E8A-4147-A177-3AD203B41FA5}">
+                      <a16:colId xmlns:a16="http://schemas.microsoft.com/office/drawing/2014/main" val="20002"/>
+                    </a:ext>
+                  </a:extLst>
+                </a:gridCol>
+                <a:gridCol w="1892807">
+                  <a:extLst>
+                    <a:ext uri="{9D8B030D-6E8A-4147-A177-3AD203B41FA5}">
+                      <a16:colId xmlns:a16="http://schemas.microsoft.com/office/drawing/2014/main" val="20003"/>
+                    </a:ext>
+                  </a:extLst>
+                </a:gridCol>
               </a:tblGrid>
               <a:tr h="704088">
                 <a:tc>
                   <a:txBody>
-                    <a:bodyPr anchor="ctr"/>
+                    <a:bodyPr/>
                     <a:lstStyle/>
                     <a:p>
                       <a:pPr algn="ctr"/>
@@ -11125,7 +11001,7 @@
                 </a:tc>
                 <a:tc>
                   <a:txBody>
-                    <a:bodyPr anchor="ctr"/>
+                    <a:bodyPr/>
                     <a:lstStyle/>
                     <a:p>
                       <a:pPr algn="ctr"/>
@@ -11149,7 +11025,7 @@
                 </a:tc>
                 <a:tc>
                   <a:txBody>
-                    <a:bodyPr anchor="ctr"/>
+                    <a:bodyPr/>
                     <a:lstStyle/>
                     <a:p>
                       <a:pPr algn="ctr"/>
@@ -11173,7 +11049,7 @@
                 </a:tc>
                 <a:tc>
                   <a:txBody>
-                    <a:bodyPr anchor="ctr"/>
+                    <a:bodyPr/>
                     <a:lstStyle/>
                     <a:p>
                       <a:pPr algn="ctr"/>
@@ -11195,11 +11071,16 @@
                     </a:solidFill>
                   </a:tcPr>
                 </a:tc>
+                <a:extLst>
+                  <a:ext uri="{0D108BD9-81ED-4DB2-BD59-A6C34878D82A}">
+                    <a16:rowId xmlns:a16="http://schemas.microsoft.com/office/drawing/2014/main" val="10000"/>
+                  </a:ext>
+                </a:extLst>
               </a:tr>
               <a:tr h="704088">
                 <a:tc>
                   <a:txBody>
-                    <a:bodyPr anchor="ctr"/>
+                    <a:bodyPr/>
                     <a:lstStyle/>
                     <a:p>
                       <a:pPr algn="l"/>
@@ -11223,7 +11104,7 @@
                 </a:tc>
                 <a:tc>
                   <a:txBody>
-                    <a:bodyPr anchor="ctr"/>
+                    <a:bodyPr/>
                     <a:lstStyle/>
                     <a:p>
                       <a:pPr algn="ctr"/>
@@ -11247,7 +11128,7 @@
                 </a:tc>
                 <a:tc>
                   <a:txBody>
-                    <a:bodyPr anchor="ctr"/>
+                    <a:bodyPr/>
                     <a:lstStyle/>
                     <a:p>
                       <a:pPr algn="ctr"/>
@@ -11271,7 +11152,7 @@
                 </a:tc>
                 <a:tc>
                   <a:txBody>
-                    <a:bodyPr anchor="ctr"/>
+                    <a:bodyPr/>
                     <a:lstStyle/>
                     <a:p>
                       <a:pPr algn="ctr"/>
@@ -11293,11 +11174,16 @@
                     </a:solidFill>
                   </a:tcPr>
                 </a:tc>
+                <a:extLst>
+                  <a:ext uri="{0D108BD9-81ED-4DB2-BD59-A6C34878D82A}">
+                    <a16:rowId xmlns:a16="http://schemas.microsoft.com/office/drawing/2014/main" val="10001"/>
+                  </a:ext>
+                </a:extLst>
               </a:tr>
               <a:tr h="704088">
                 <a:tc>
                   <a:txBody>
-                    <a:bodyPr anchor="ctr"/>
+                    <a:bodyPr/>
                     <a:lstStyle/>
                     <a:p>
                       <a:pPr algn="l"/>
@@ -11321,7 +11207,7 @@
                 </a:tc>
                 <a:tc>
                   <a:txBody>
-                    <a:bodyPr anchor="ctr"/>
+                    <a:bodyPr/>
                     <a:lstStyle/>
                     <a:p>
                       <a:pPr algn="ctr"/>
@@ -11345,7 +11231,7 @@
                 </a:tc>
                 <a:tc>
                   <a:txBody>
-                    <a:bodyPr anchor="ctr"/>
+                    <a:bodyPr/>
                     <a:lstStyle/>
                     <a:p>
                       <a:pPr algn="ctr"/>
@@ -11369,7 +11255,7 @@
                 </a:tc>
                 <a:tc>
                   <a:txBody>
-                    <a:bodyPr anchor="ctr"/>
+                    <a:bodyPr/>
                     <a:lstStyle/>
                     <a:p>
                       <a:pPr algn="ctr"/>
@@ -11391,11 +11277,16 @@
                     </a:solidFill>
                   </a:tcPr>
                 </a:tc>
+                <a:extLst>
+                  <a:ext uri="{0D108BD9-81ED-4DB2-BD59-A6C34878D82A}">
+                    <a16:rowId xmlns:a16="http://schemas.microsoft.com/office/drawing/2014/main" val="10002"/>
+                  </a:ext>
+                </a:extLst>
               </a:tr>
               <a:tr h="704088">
                 <a:tc>
                   <a:txBody>
-                    <a:bodyPr anchor="ctr"/>
+                    <a:bodyPr/>
                     <a:lstStyle/>
                     <a:p>
                       <a:pPr algn="l"/>
@@ -11419,7 +11310,7 @@
                 </a:tc>
                 <a:tc>
                   <a:txBody>
-                    <a:bodyPr anchor="ctr"/>
+                    <a:bodyPr/>
                     <a:lstStyle/>
                     <a:p>
                       <a:pPr algn="ctr"/>
@@ -11443,7 +11334,7 @@
                 </a:tc>
                 <a:tc>
                   <a:txBody>
-                    <a:bodyPr anchor="ctr"/>
+                    <a:bodyPr/>
                     <a:lstStyle/>
                     <a:p>
                       <a:pPr algn="ctr"/>
@@ -11467,7 +11358,7 @@
                 </a:tc>
                 <a:tc>
                   <a:txBody>
-                    <a:bodyPr anchor="ctr"/>
+                    <a:bodyPr/>
                     <a:lstStyle/>
                     <a:p>
                       <a:pPr algn="ctr"/>
@@ -11489,11 +11380,16 @@
                     </a:solidFill>
                   </a:tcPr>
                 </a:tc>
+                <a:extLst>
+                  <a:ext uri="{0D108BD9-81ED-4DB2-BD59-A6C34878D82A}">
+                    <a16:rowId xmlns:a16="http://schemas.microsoft.com/office/drawing/2014/main" val="10003"/>
+                  </a:ext>
+                </a:extLst>
               </a:tr>
               <a:tr h="704088">
                 <a:tc>
                   <a:txBody>
-                    <a:bodyPr anchor="ctr"/>
+                    <a:bodyPr/>
                     <a:lstStyle/>
                     <a:p>
                       <a:pPr algn="l"/>
@@ -11517,7 +11413,7 @@
                 </a:tc>
                 <a:tc>
                   <a:txBody>
-                    <a:bodyPr anchor="ctr"/>
+                    <a:bodyPr/>
                     <a:lstStyle/>
                     <a:p>
                       <a:pPr algn="ctr"/>
@@ -11541,7 +11437,7 @@
                 </a:tc>
                 <a:tc>
                   <a:txBody>
-                    <a:bodyPr anchor="ctr"/>
+                    <a:bodyPr/>
                     <a:lstStyle/>
                     <a:p>
                       <a:pPr algn="ctr"/>
@@ -11565,7 +11461,7 @@
                 </a:tc>
                 <a:tc>
                   <a:txBody>
-                    <a:bodyPr anchor="ctr"/>
+                    <a:bodyPr/>
                     <a:lstStyle/>
                     <a:p>
                       <a:pPr algn="ctr"/>
@@ -11587,11 +11483,16 @@
                     </a:solidFill>
                   </a:tcPr>
                 </a:tc>
+                <a:extLst>
+                  <a:ext uri="{0D108BD9-81ED-4DB2-BD59-A6C34878D82A}">
+                    <a16:rowId xmlns:a16="http://schemas.microsoft.com/office/drawing/2014/main" val="10004"/>
+                  </a:ext>
+                </a:extLst>
               </a:tr>
               <a:tr h="704088">
                 <a:tc>
                   <a:txBody>
-                    <a:bodyPr anchor="ctr"/>
+                    <a:bodyPr/>
                     <a:lstStyle/>
                     <a:p>
                       <a:pPr algn="l"/>
@@ -11615,7 +11516,7 @@
                 </a:tc>
                 <a:tc>
                   <a:txBody>
-                    <a:bodyPr anchor="ctr"/>
+                    <a:bodyPr/>
                     <a:lstStyle/>
                     <a:p>
                       <a:pPr algn="ctr"/>
@@ -11639,7 +11540,7 @@
                 </a:tc>
                 <a:tc>
                   <a:txBody>
-                    <a:bodyPr anchor="ctr"/>
+                    <a:bodyPr/>
                     <a:lstStyle/>
                     <a:p>
                       <a:pPr algn="ctr"/>
@@ -11663,7 +11564,7 @@
                 </a:tc>
                 <a:tc>
                   <a:txBody>
-                    <a:bodyPr anchor="ctr"/>
+                    <a:bodyPr/>
                     <a:lstStyle/>
                     <a:p>
                       <a:pPr algn="ctr"/>
@@ -11685,6 +11586,11 @@
                     </a:solidFill>
                   </a:tcPr>
                 </a:tc>
+                <a:extLst>
+                  <a:ext uri="{0D108BD9-81ED-4DB2-BD59-A6C34878D82A}">
+                    <a16:rowId xmlns:a16="http://schemas.microsoft.com/office/drawing/2014/main" val="10005"/>
+                  </a:ext>
+                </a:extLst>
               </a:tr>
             </a:tbl>
           </a:graphicData>
@@ -11734,6 +11640,7 @@
           <a:lstStyle/>
           <a:p>
             <a:pPr algn="ctr"/>
+            <a:endParaRPr/>
           </a:p>
         </p:txBody>
       </p:sp>
@@ -11754,7 +11661,7 @@
           <a:noFill/>
         </p:spPr>
         <p:txBody>
-          <a:bodyPr wrap="square" lIns="0" rIns="0" tIns="0" bIns="0" anchor="t">
+          <a:bodyPr wrap="square" lIns="0" tIns="0" rIns="0" bIns="0" anchor="t">
             <a:spAutoFit/>
           </a:bodyPr>
           <a:lstStyle/>
@@ -11800,7 +11707,7 @@
           <a:noFill/>
         </p:spPr>
         <p:txBody>
-          <a:bodyPr wrap="square" lIns="0" rIns="0" tIns="0" bIns="0" anchor="t">
+          <a:bodyPr wrap="square" lIns="0" tIns="0" rIns="0" bIns="0" anchor="t">
             <a:spAutoFit/>
           </a:bodyPr>
           <a:lstStyle/>
@@ -11846,7 +11753,7 @@
           <a:noFill/>
         </p:spPr>
         <p:txBody>
-          <a:bodyPr wrap="square" lIns="0" rIns="0" tIns="0" bIns="0" anchor="t">
+          <a:bodyPr wrap="square" lIns="0" tIns="0" rIns="0" bIns="0" anchor="t">
             <a:spAutoFit/>
           </a:bodyPr>
           <a:lstStyle/>
@@ -11919,6 +11826,7 @@
           <a:lstStyle/>
           <a:p>
             <a:pPr algn="ctr"/>
+            <a:endParaRPr/>
           </a:p>
         </p:txBody>
       </p:sp>
@@ -11939,7 +11847,7 @@
           <a:noFill/>
         </p:spPr>
         <p:txBody>
-          <a:bodyPr wrap="square" lIns="0" rIns="0" tIns="0" bIns="0" anchor="t">
+          <a:bodyPr wrap="square" lIns="0" tIns="0" rIns="0" bIns="0" anchor="t">
             <a:spAutoFit/>
           </a:bodyPr>
           <a:lstStyle/>
@@ -11985,7 +11893,7 @@
           <a:noFill/>
         </p:spPr>
         <p:txBody>
-          <a:bodyPr wrap="square" lIns="0" rIns="0" tIns="0" bIns="0" anchor="t">
+          <a:bodyPr wrap="square" lIns="0" tIns="0" rIns="0" bIns="0" anchor="t">
             <a:spAutoFit/>
           </a:bodyPr>
           <a:lstStyle/>
@@ -12031,7 +11939,7 @@
           <a:noFill/>
         </p:spPr>
         <p:txBody>
-          <a:bodyPr wrap="square" lIns="0" rIns="0" tIns="0" bIns="0" anchor="t">
+          <a:bodyPr wrap="square" lIns="0" tIns="0" rIns="0" bIns="0" anchor="t">
             <a:spAutoFit/>
           </a:bodyPr>
           <a:lstStyle/>
@@ -12077,7 +11985,7 @@
           <a:noFill/>
         </p:spPr>
         <p:txBody>
-          <a:bodyPr wrap="square" lIns="0" rIns="0" tIns="0" bIns="0" anchor="t">
+          <a:bodyPr wrap="square" lIns="0" tIns="0" rIns="0" bIns="0" anchor="t">
             <a:spAutoFit/>
           </a:bodyPr>
           <a:lstStyle/>
@@ -12115,7 +12023,7 @@
 </file>
 
 <file path=ppt/slides/slide8.xml><?xml version="1.0" encoding="utf-8"?>
-<p:sld xmlns:a="http://schemas.openxmlformats.org/drawingml/2006/main" xmlns:p="http://schemas.openxmlformats.org/presentationml/2006/main" xmlns:r="http://schemas.openxmlformats.org/officeDocument/2006/relationships">
+<p:sld xmlns:a="http://schemas.openxmlformats.org/drawingml/2006/main" xmlns:r="http://schemas.openxmlformats.org/officeDocument/2006/relationships" xmlns:p="http://schemas.openxmlformats.org/presentationml/2006/main">
   <p:cSld>
     <p:spTree>
       <p:nvGrpSpPr>
@@ -12123,7 +12031,14 @@
         <p:cNvGrpSpPr/>
         <p:nvPr/>
       </p:nvGrpSpPr>
-      <p:grpSpPr/>
+      <p:grpSpPr>
+        <a:xfrm>
+          <a:off x="0" y="0"/>
+          <a:ext cx="0" cy="0"/>
+          <a:chOff x="0" y="0"/>
+          <a:chExt cx="0" cy="0"/>
+        </a:xfrm>
+      </p:grpSpPr>
       <p:sp>
         <p:nvSpPr>
           <p:cNvPr id="2" name="TextBox 1"/>
@@ -12141,7 +12056,7 @@
           <a:noFill/>
         </p:spPr>
         <p:txBody>
-          <a:bodyPr wrap="square" lIns="0" rIns="0" tIns="0" bIns="0" anchor="t">
+          <a:bodyPr wrap="square" lIns="0" tIns="0" rIns="0" bIns="0" anchor="t">
             <a:spAutoFit/>
           </a:bodyPr>
           <a:lstStyle/>
@@ -12187,7 +12102,7 @@
           <a:noFill/>
         </p:spPr>
         <p:txBody>
-          <a:bodyPr wrap="square" lIns="0" rIns="0" tIns="0" bIns="0" anchor="ctr">
+          <a:bodyPr wrap="square" lIns="0" tIns="0" rIns="0" bIns="0" anchor="ctr">
             <a:spAutoFit/>
           </a:bodyPr>
           <a:lstStyle/>
@@ -12303,7 +12218,7 @@
           <a:noFill/>
         </p:spPr>
         <p:txBody>
-          <a:bodyPr wrap="square" lIns="0" rIns="0" tIns="0" bIns="0" anchor="t">
+          <a:bodyPr wrap="square" lIns="0" tIns="0" rIns="0" bIns="0" anchor="t">
             <a:spAutoFit/>
           </a:bodyPr>
           <a:lstStyle/>
@@ -12349,7 +12264,7 @@
           <a:noFill/>
         </p:spPr>
         <p:txBody>
-          <a:bodyPr wrap="square" lIns="0" rIns="0" tIns="0" bIns="0" anchor="t">
+          <a:bodyPr wrap="square" lIns="0" tIns="0" rIns="0" bIns="0" anchor="t">
             <a:spAutoFit/>
           </a:bodyPr>
           <a:lstStyle/>
@@ -12395,7 +12310,7 @@
           <a:noFill/>
         </p:spPr>
         <p:txBody>
-          <a:bodyPr wrap="square" lIns="0" rIns="0" tIns="0" bIns="0" anchor="t">
+          <a:bodyPr wrap="square" lIns="0" tIns="0" rIns="0" bIns="0" anchor="t">
             <a:spAutoFit/>
           </a:bodyPr>
           <a:lstStyle/>
@@ -12468,6 +12383,7 @@
           <a:lstStyle/>
           <a:p>
             <a:pPr algn="ctr"/>
+            <a:endParaRPr/>
           </a:p>
         </p:txBody>
       </p:sp>
@@ -12488,7 +12404,7 @@
           <a:noFill/>
         </p:spPr>
         <p:txBody>
-          <a:bodyPr wrap="square" lIns="0" rIns="0" tIns="0" bIns="0" anchor="t">
+          <a:bodyPr wrap="square" lIns="0" tIns="0" rIns="0" bIns="0" anchor="t">
             <a:spAutoFit/>
           </a:bodyPr>
           <a:lstStyle/>
@@ -12534,7 +12450,7 @@
           <a:noFill/>
         </p:spPr>
         <p:txBody>
-          <a:bodyPr wrap="square" lIns="0" rIns="0" tIns="0" bIns="0" anchor="t">
+          <a:bodyPr wrap="square" lIns="0" tIns="0" rIns="0" bIns="0" anchor="t">
             <a:spAutoFit/>
           </a:bodyPr>
           <a:lstStyle/>
@@ -12630,6 +12546,7 @@
           <a:lstStyle/>
           <a:p>
             <a:pPr algn="ctr"/>
+            <a:endParaRPr/>
           </a:p>
         </p:txBody>
       </p:sp>
@@ -12650,7 +12567,7 @@
           <a:noFill/>
         </p:spPr>
         <p:txBody>
-          <a:bodyPr wrap="square" lIns="0" rIns="0" tIns="0" bIns="0" anchor="t">
+          <a:bodyPr wrap="square" lIns="0" tIns="0" rIns="0" bIns="0" anchor="t">
             <a:spAutoFit/>
           </a:bodyPr>
           <a:lstStyle/>
@@ -12696,7 +12613,7 @@
           <a:noFill/>
         </p:spPr>
         <p:txBody>
-          <a:bodyPr wrap="square" lIns="0" rIns="0" tIns="0" bIns="0" anchor="ctr">
+          <a:bodyPr wrap="square" lIns="0" tIns="0" rIns="0" bIns="0" anchor="ctr">
             <a:spAutoFit/>
           </a:bodyPr>
           <a:lstStyle/>
@@ -12742,7 +12659,7 @@
           <a:noFill/>
         </p:spPr>
         <p:txBody>
-          <a:bodyPr wrap="square" lIns="0" rIns="0" tIns="0" bIns="0" anchor="t">
+          <a:bodyPr wrap="square" lIns="0" tIns="0" rIns="0" bIns="0" anchor="t">
             <a:spAutoFit/>
           </a:bodyPr>
           <a:lstStyle/>
@@ -12815,6 +12732,7 @@
           <a:lstStyle/>
           <a:p>
             <a:pPr algn="ctr"/>
+            <a:endParaRPr/>
           </a:p>
         </p:txBody>
       </p:sp>
@@ -12835,7 +12753,7 @@
           <a:noFill/>
         </p:spPr>
         <p:txBody>
-          <a:bodyPr wrap="square" lIns="0" rIns="0" tIns="0" bIns="0" anchor="t">
+          <a:bodyPr wrap="square" lIns="0" tIns="0" rIns="0" bIns="0" anchor="t">
             <a:spAutoFit/>
           </a:bodyPr>
           <a:lstStyle/>
@@ -12881,7 +12799,7 @@
           <a:noFill/>
         </p:spPr>
         <p:txBody>
-          <a:bodyPr wrap="square" lIns="0" rIns="0" tIns="0" bIns="0" anchor="t">
+          <a:bodyPr wrap="square" lIns="0" tIns="0" rIns="0" bIns="0" anchor="t">
             <a:spAutoFit/>
           </a:bodyPr>
           <a:lstStyle/>
@@ -12927,7 +12845,7 @@
           <a:noFill/>
         </p:spPr>
         <p:txBody>
-          <a:bodyPr wrap="square" lIns="0" rIns="0" tIns="0" bIns="0" anchor="t">
+          <a:bodyPr wrap="square" lIns="0" tIns="0" rIns="0" bIns="0" anchor="t">
             <a:spAutoFit/>
           </a:bodyPr>
           <a:lstStyle/>
@@ -13000,6 +12918,7 @@
           <a:lstStyle/>
           <a:p>
             <a:pPr algn="ctr"/>
+            <a:endParaRPr/>
           </a:p>
         </p:txBody>
       </p:sp>
@@ -13020,7 +12939,7 @@
           <a:noFill/>
         </p:spPr>
         <p:txBody>
-          <a:bodyPr wrap="square" lIns="0" rIns="0" tIns="0" bIns="0" anchor="t">
+          <a:bodyPr wrap="square" lIns="0" tIns="0" rIns="0" bIns="0" anchor="t">
             <a:spAutoFit/>
           </a:bodyPr>
           <a:lstStyle/>
@@ -13066,7 +12985,7 @@
           <a:noFill/>
         </p:spPr>
         <p:txBody>
-          <a:bodyPr wrap="square" lIns="0" rIns="0" tIns="0" bIns="0" anchor="t">
+          <a:bodyPr wrap="square" lIns="0" tIns="0" rIns="0" bIns="0" anchor="t">
             <a:spAutoFit/>
           </a:bodyPr>
           <a:lstStyle/>
@@ -13112,7 +13031,7 @@
           <a:noFill/>
         </p:spPr>
         <p:txBody>
-          <a:bodyPr wrap="square" lIns="0" rIns="0" tIns="0" bIns="0" anchor="t">
+          <a:bodyPr wrap="square" lIns="0" tIns="0" rIns="0" bIns="0" anchor="t">
             <a:spAutoFit/>
           </a:bodyPr>
           <a:lstStyle/>
@@ -13185,6 +13104,7 @@
           <a:lstStyle/>
           <a:p>
             <a:pPr algn="ctr"/>
+            <a:endParaRPr/>
           </a:p>
         </p:txBody>
       </p:sp>
@@ -13205,7 +13125,7 @@
           <a:noFill/>
         </p:spPr>
         <p:txBody>
-          <a:bodyPr wrap="square" lIns="0" rIns="0" tIns="0" bIns="0" anchor="t">
+          <a:bodyPr wrap="square" lIns="0" tIns="0" rIns="0" bIns="0" anchor="t">
             <a:spAutoFit/>
           </a:bodyPr>
           <a:lstStyle/>
@@ -13251,7 +13171,7 @@
           <a:noFill/>
         </p:spPr>
         <p:txBody>
-          <a:bodyPr wrap="square" lIns="0" rIns="0" tIns="0" bIns="0" anchor="t">
+          <a:bodyPr wrap="square" lIns="0" tIns="0" rIns="0" bIns="0" anchor="t">
             <a:spAutoFit/>
           </a:bodyPr>
           <a:lstStyle/>
@@ -13297,7 +13217,7 @@
           <a:noFill/>
         </p:spPr>
         <p:txBody>
-          <a:bodyPr wrap="square" lIns="0" rIns="0" tIns="0" bIns="0" anchor="t">
+          <a:bodyPr wrap="square" lIns="0" tIns="0" rIns="0" bIns="0" anchor="t">
             <a:spAutoFit/>
           </a:bodyPr>
           <a:lstStyle/>
@@ -13343,7 +13263,7 @@
           <a:noFill/>
         </p:spPr>
         <p:txBody>
-          <a:bodyPr wrap="square" lIns="0" rIns="0" tIns="0" bIns="0" anchor="t">
+          <a:bodyPr wrap="square" lIns="0" tIns="0" rIns="0" bIns="0" anchor="t">
             <a:spAutoFit/>
           </a:bodyPr>
           <a:lstStyle/>
@@ -13701,7 +13621,7 @@
 </file>
 
 <file path=ppt/theme/theme2.xml><?xml version="1.0" encoding="utf-8"?>
-<a:theme xmlns:a="http://schemas.openxmlformats.org/drawingml/2006/main" name="Office Theme">
+<a:theme xmlns:a="http://schemas.openxmlformats.org/drawingml/2006/main" name="Office 主题​​">
   <a:themeElements>
     <a:clrScheme name="Office">
       <a:dk1>
@@ -13711,44 +13631,44 @@
         <a:sysClr val="window" lastClr="FFFFFF"/>
       </a:lt1>
       <a:dk2>
-        <a:srgbClr val="1F497D"/>
+        <a:srgbClr val="44546A"/>
       </a:dk2>
       <a:lt2>
-        <a:srgbClr val="EEECE1"/>
+        <a:srgbClr val="E7E6E6"/>
       </a:lt2>
       <a:accent1>
-        <a:srgbClr val="4F81BD"/>
+        <a:srgbClr val="4472C4"/>
       </a:accent1>
       <a:accent2>
-        <a:srgbClr val="C0504D"/>
+        <a:srgbClr val="ED7D31"/>
       </a:accent2>
       <a:accent3>
-        <a:srgbClr val="9BBB59"/>
+        <a:srgbClr val="A5A5A5"/>
       </a:accent3>
       <a:accent4>
-        <a:srgbClr val="8064A2"/>
+        <a:srgbClr val="FFC000"/>
       </a:accent4>
       <a:accent5>
-        <a:srgbClr val="4BACC6"/>
+        <a:srgbClr val="5B9BD5"/>
       </a:accent5>
       <a:accent6>
-        <a:srgbClr val="F79646"/>
+        <a:srgbClr val="70AD47"/>
       </a:accent6>
       <a:hlink>
-        <a:srgbClr val="0000FF"/>
+        <a:srgbClr val="0563C1"/>
       </a:hlink>
       <a:folHlink>
-        <a:srgbClr val="800080"/>
+        <a:srgbClr val="954F72"/>
       </a:folHlink>
     </a:clrScheme>
     <a:fontScheme name="Office">
       <a:majorFont>
-        <a:latin typeface="Calibri"/>
+        <a:latin typeface="等线 Light" panose="020F0302020204030204"/>
         <a:ea typeface=""/>
         <a:cs typeface=""/>
-        <a:font script="Jpan" typeface="ＭＳ Ｐゴシック"/>
+        <a:font script="Jpan" typeface="游ゴシック Light"/>
         <a:font script="Hang" typeface="맑은 고딕"/>
-        <a:font script="Hans" typeface="宋体"/>
+        <a:font script="Hans" typeface="等线 Light"/>
         <a:font script="Hant" typeface="新細明體"/>
         <a:font script="Arab" typeface="Times New Roman"/>
         <a:font script="Hebr" typeface="Times New Roman"/>
@@ -13776,14 +13696,31 @@
         <a:font script="Viet" typeface="Times New Roman"/>
         <a:font script="Uigh" typeface="Microsoft Uighur"/>
         <a:font script="Geor" typeface="Sylfaen"/>
+        <a:font script="Armn" typeface="Arial"/>
+        <a:font script="Bugi" typeface="Leelawadee UI"/>
+        <a:font script="Bopo" typeface="Microsoft JhengHei"/>
+        <a:font script="Java" typeface="Javanese Text"/>
+        <a:font script="Lisu" typeface="Segoe UI"/>
+        <a:font script="Mymr" typeface="Myanmar Text"/>
+        <a:font script="Nkoo" typeface="Ebrima"/>
+        <a:font script="Olck" typeface="Nirmala UI"/>
+        <a:font script="Osma" typeface="Ebrima"/>
+        <a:font script="Phag" typeface="Phagspa"/>
+        <a:font script="Syrn" typeface="Estrangelo Edessa"/>
+        <a:font script="Syrj" typeface="Estrangelo Edessa"/>
+        <a:font script="Syre" typeface="Estrangelo Edessa"/>
+        <a:font script="Sora" typeface="Nirmala UI"/>
+        <a:font script="Tale" typeface="Microsoft Tai Le"/>
+        <a:font script="Talu" typeface="Microsoft New Tai Lue"/>
+        <a:font script="Tfng" typeface="Ebrima"/>
       </a:majorFont>
       <a:minorFont>
-        <a:latin typeface="Calibri"/>
+        <a:latin typeface="等线" panose="020F0502020204030204"/>
         <a:ea typeface=""/>
         <a:cs typeface=""/>
-        <a:font script="Jpan" typeface="ＭＳ Ｐゴシック"/>
+        <a:font script="Jpan" typeface="游ゴシック"/>
         <a:font script="Hang" typeface="맑은 고딕"/>
-        <a:font script="Hans" typeface="宋体"/>
+        <a:font script="Hans" typeface="等线"/>
         <a:font script="Hant" typeface="新細明體"/>
         <a:font script="Arab" typeface="Arial"/>
         <a:font script="Hebr" typeface="Arial"/>
@@ -13811,6 +13748,23 @@
         <a:font script="Viet" typeface="Arial"/>
         <a:font script="Uigh" typeface="Microsoft Uighur"/>
         <a:font script="Geor" typeface="Sylfaen"/>
+        <a:font script="Armn" typeface="Arial"/>
+        <a:font script="Bugi" typeface="Leelawadee UI"/>
+        <a:font script="Bopo" typeface="Microsoft JhengHei"/>
+        <a:font script="Java" typeface="Javanese Text"/>
+        <a:font script="Lisu" typeface="Segoe UI"/>
+        <a:font script="Mymr" typeface="Myanmar Text"/>
+        <a:font script="Nkoo" typeface="Ebrima"/>
+        <a:font script="Olck" typeface="Nirmala UI"/>
+        <a:font script="Osma" typeface="Ebrima"/>
+        <a:font script="Phag" typeface="Phagspa"/>
+        <a:font script="Syrn" typeface="Estrangelo Edessa"/>
+        <a:font script="Syrj" typeface="Estrangelo Edessa"/>
+        <a:font script="Syre" typeface="Estrangelo Edessa"/>
+        <a:font script="Sora" typeface="Nirmala UI"/>
+        <a:font script="Tale" typeface="Microsoft Tai Le"/>
+        <a:font script="Talu" typeface="Microsoft New Tai Lue"/>
+        <a:font script="Tfng" typeface="Ebrima"/>
       </a:minorFont>
     </a:fontScheme>
     <a:fmtScheme name="Office">
@@ -13822,200 +13776,141 @@
           <a:gsLst>
             <a:gs pos="0">
               <a:schemeClr val="phClr">
-                <a:tint val="50000"/>
-                <a:satMod val="300000"/>
+                <a:lumMod val="110000"/>
+                <a:satMod val="105000"/>
+                <a:tint val="67000"/>
               </a:schemeClr>
             </a:gs>
-            <a:gs pos="35000">
+            <a:gs pos="50000">
               <a:schemeClr val="phClr">
-                <a:tint val="37000"/>
-                <a:satMod val="300000"/>
+                <a:lumMod val="105000"/>
+                <a:satMod val="103000"/>
+                <a:tint val="73000"/>
               </a:schemeClr>
             </a:gs>
             <a:gs pos="100000">
               <a:schemeClr val="phClr">
-                <a:tint val="15000"/>
-                <a:satMod val="350000"/>
+                <a:lumMod val="105000"/>
+                <a:satMod val="109000"/>
+                <a:tint val="81000"/>
               </a:schemeClr>
             </a:gs>
           </a:gsLst>
-          <a:lin ang="16200000" scaled="1"/>
+          <a:lin ang="5400000" scaled="0"/>
         </a:gradFill>
         <a:gradFill rotWithShape="1">
           <a:gsLst>
             <a:gs pos="0">
               <a:schemeClr val="phClr">
-                <a:tint val="100000"/>
+                <a:satMod val="103000"/>
+                <a:lumMod val="102000"/>
+                <a:tint val="94000"/>
+              </a:schemeClr>
+            </a:gs>
+            <a:gs pos="50000">
+              <a:schemeClr val="phClr">
+                <a:satMod val="110000"/>
+                <a:lumMod val="100000"/>
                 <a:shade val="100000"/>
-                <a:satMod val="130000"/>
               </a:schemeClr>
             </a:gs>
             <a:gs pos="100000">
               <a:schemeClr val="phClr">
-                <a:tint val="50000"/>
-                <a:shade val="100000"/>
-                <a:satMod val="350000"/>
+                <a:lumMod val="99000"/>
+                <a:satMod val="120000"/>
+                <a:shade val="78000"/>
               </a:schemeClr>
             </a:gs>
           </a:gsLst>
-          <a:lin ang="16200000" scaled="0"/>
+          <a:lin ang="5400000" scaled="0"/>
         </a:gradFill>
       </a:fillStyleLst>
       <a:lnStyleLst>
-        <a:ln w="9525" cap="flat" cmpd="sng" algn="ctr">
-          <a:solidFill>
-            <a:schemeClr val="phClr">
-              <a:shade val="95000"/>
-              <a:satMod val="105000"/>
-            </a:schemeClr>
-          </a:solidFill>
-          <a:prstDash val="solid"/>
-        </a:ln>
-        <a:ln w="25400" cap="flat" cmpd="sng" algn="ctr">
+        <a:ln w="6350" cap="flat" cmpd="sng" algn="ctr">
           <a:solidFill>
             <a:schemeClr val="phClr"/>
           </a:solidFill>
           <a:prstDash val="solid"/>
+          <a:miter lim="800000"/>
         </a:ln>
-        <a:ln w="38100" cap="flat" cmpd="sng" algn="ctr">
+        <a:ln w="12700" cap="flat" cmpd="sng" algn="ctr">
           <a:solidFill>
             <a:schemeClr val="phClr"/>
           </a:solidFill>
           <a:prstDash val="solid"/>
+          <a:miter lim="800000"/>
+        </a:ln>
+        <a:ln w="19050" cap="flat" cmpd="sng" algn="ctr">
+          <a:solidFill>
+            <a:schemeClr val="phClr"/>
+          </a:solidFill>
+          <a:prstDash val="solid"/>
+          <a:miter lim="800000"/>
         </a:ln>
       </a:lnStyleLst>
       <a:effectStyleLst>
         <a:effectStyle>
+          <a:effectLst/>
+        </a:effectStyle>
+        <a:effectStyle>
+          <a:effectLst/>
+        </a:effectStyle>
+        <a:effectStyle>
           <a:effectLst>
-            <a:outerShdw blurRad="40000" dist="20000" dir="5400000" rotWithShape="0">
+            <a:outerShdw blurRad="57150" dist="19050" dir="5400000" algn="ctr" rotWithShape="0">
               <a:srgbClr val="000000">
-                <a:alpha val="38000"/>
+                <a:alpha val="63000"/>
               </a:srgbClr>
             </a:outerShdw>
           </a:effectLst>
-        </a:effectStyle>
-        <a:effectStyle>
-          <a:effectLst>
-            <a:outerShdw blurRad="40000" dist="23000" dir="5400000" rotWithShape="0">
-              <a:srgbClr val="000000">
-                <a:alpha val="35000"/>
-              </a:srgbClr>
-            </a:outerShdw>
-          </a:effectLst>
-        </a:effectStyle>
-        <a:effectStyle>
-          <a:effectLst>
-            <a:outerShdw blurRad="40000" dist="23000" dir="5400000" rotWithShape="0">
-              <a:srgbClr val="000000">
-                <a:alpha val="35000"/>
-              </a:srgbClr>
-            </a:outerShdw>
-          </a:effectLst>
-          <a:scene3d>
-            <a:camera prst="orthographicFront">
-              <a:rot lat="0" lon="0" rev="0"/>
-            </a:camera>
-            <a:lightRig rig="threePt" dir="t">
-              <a:rot lat="0" lon="0" rev="1200000"/>
-            </a:lightRig>
-          </a:scene3d>
-          <a:sp3d>
-            <a:bevelT w="63500" h="25400"/>
-          </a:sp3d>
         </a:effectStyle>
       </a:effectStyleLst>
       <a:bgFillStyleLst>
         <a:solidFill>
           <a:schemeClr val="phClr"/>
         </a:solidFill>
+        <a:solidFill>
+          <a:schemeClr val="phClr">
+            <a:tint val="95000"/>
+            <a:satMod val="170000"/>
+          </a:schemeClr>
+        </a:solidFill>
         <a:gradFill rotWithShape="1">
           <a:gsLst>
             <a:gs pos="0">
               <a:schemeClr val="phClr">
-                <a:tint val="40000"/>
-                <a:satMod val="350000"/>
+                <a:tint val="93000"/>
+                <a:satMod val="150000"/>
+                <a:shade val="98000"/>
+                <a:lumMod val="102000"/>
               </a:schemeClr>
             </a:gs>
-            <a:gs pos="40000">
+            <a:gs pos="50000">
               <a:schemeClr val="phClr">
-                <a:tint val="45000"/>
-                <a:shade val="99000"/>
-                <a:satMod val="350000"/>
+                <a:tint val="98000"/>
+                <a:satMod val="130000"/>
+                <a:shade val="90000"/>
+                <a:lumMod val="103000"/>
               </a:schemeClr>
             </a:gs>
             <a:gs pos="100000">
               <a:schemeClr val="phClr">
-                <a:shade val="20000"/>
-                <a:satMod val="255000"/>
+                <a:shade val="63000"/>
+                <a:satMod val="120000"/>
               </a:schemeClr>
             </a:gs>
           </a:gsLst>
-          <a:path path="circle">
-            <a:fillToRect l="50000" t="-80000" r="50000" b="180000"/>
-          </a:path>
-        </a:gradFill>
-        <a:gradFill rotWithShape="1">
-          <a:gsLst>
-            <a:gs pos="0">
-              <a:schemeClr val="phClr">
-                <a:tint val="80000"/>
-                <a:satMod val="300000"/>
-              </a:schemeClr>
-            </a:gs>
-            <a:gs pos="100000">
-              <a:schemeClr val="phClr">
-                <a:shade val="30000"/>
-                <a:satMod val="200000"/>
-              </a:schemeClr>
-            </a:gs>
-          </a:gsLst>
-          <a:path path="circle">
-            <a:fillToRect l="50000" t="50000" r="50000" b="50000"/>
-          </a:path>
+          <a:lin ang="5400000" scaled="0"/>
         </a:gradFill>
       </a:bgFillStyleLst>
     </a:fmtScheme>
   </a:themeElements>
-  <a:objectDefaults>
-    <a:spDef>
-      <a:spPr/>
-      <a:bodyPr/>
-      <a:lstStyle/>
-      <a:style>
-        <a:lnRef idx="1">
-          <a:schemeClr val="accent1"/>
-        </a:lnRef>
-        <a:fillRef idx="3">
-          <a:schemeClr val="accent1"/>
-        </a:fillRef>
-        <a:effectRef idx="2">
-          <a:schemeClr val="accent1"/>
-        </a:effectRef>
-        <a:fontRef idx="minor">
-          <a:schemeClr val="lt1"/>
-        </a:fontRef>
-      </a:style>
-    </a:spDef>
-    <a:lnDef>
-      <a:spPr/>
-      <a:bodyPr/>
-      <a:lstStyle/>
-      <a:style>
-        <a:lnRef idx="2">
-          <a:schemeClr val="accent1"/>
-        </a:lnRef>
-        <a:fillRef idx="0">
-          <a:schemeClr val="accent1"/>
-        </a:fillRef>
-        <a:effectRef idx="1">
-          <a:schemeClr val="accent1"/>
-        </a:effectRef>
-        <a:fontRef idx="minor">
-          <a:schemeClr val="tx1"/>
-        </a:fontRef>
-      </a:style>
-    </a:lnDef>
-  </a:objectDefaults>
+  <a:objectDefaults/>
   <a:extraClrSchemeLst/>
+  <a:extLst>
+    <a:ext uri="{05A4C25C-085E-4340-85A3-A5531E510DB2}">
+      <thm15:themeFamily xmlns:thm15="http://schemas.microsoft.com/office/thememl/2012/main" name="Office Theme" id="{62F939B6-93AF-4DB8-9C6B-D6C7DFDC589F}" vid="{4A3C46E8-61CC-4603-A589-7422A47A8E4A}"/>
+    </a:ext>
+  </a:extLst>
 </a:theme>
 </file>
</xml_diff>